<commit_message>
Align Korean portfolio labels with chart dataset names
Co-authored-by: Cursor <cursoragent@cursor.com>
</commit_message>
<xml_diff>
--- a/ppt/PP-X_Final_Research_20min.pptx
+++ b/ppt/PP-X_Final_Research_20min.pptx
@@ -4554,12 +4554,23 @@
                     <a:p>
                       <a:pPr algn="l"/>
                       <a:r>
-                        <a:rPr sz="1000" b="1">
-                          <a:solidFill>
-                            <a:srgbClr val="222222"/>
-                          </a:solidFill>
-                          <a:latin typeface="Arial"/>
-                          <a:ea typeface="AppleGothic"/>
+                        <a:rPr sz="850" b="1">
+                          <a:solidFill>
+                            <a:srgbClr val="222222"/>
+                          </a:solidFill>
+                          <a:latin typeface="Arial"/>
+                        </a:rPr>
+                        <a:t>HUST</a:t>
+                      </a:r>
+                    </a:p>
+                    <a:p>
+                      <a:pPr algn="l"/>
+                      <a:r>
+                        <a:rPr sz="850" b="1">
+                          <a:solidFill>
+                            <a:srgbClr val="222222"/>
+                          </a:solidFill>
+                          <a:latin typeface="Arial"/>
                         </a:rPr>
                         <a:t>화중 배터리</a:t>
                       </a:r>
@@ -4628,12 +4639,23 @@
                     <a:p>
                       <a:pPr algn="l"/>
                       <a:r>
-                        <a:rPr sz="1000" b="1">
-                          <a:solidFill>
-                            <a:srgbClr val="222222"/>
-                          </a:solidFill>
-                          <a:latin typeface="Arial"/>
-                          <a:ea typeface="AppleGothic"/>
+                        <a:rPr sz="850" b="1">
+                          <a:solidFill>
+                            <a:srgbClr val="222222"/>
+                          </a:solidFill>
+                          <a:latin typeface="Arial"/>
+                        </a:rPr>
+                        <a:t>Sunwoda</a:t>
+                      </a:r>
+                    </a:p>
+                    <a:p>
+                      <a:pPr algn="l"/>
+                      <a:r>
+                        <a:rPr sz="850" b="1">
+                          <a:solidFill>
+                            <a:srgbClr val="222222"/>
+                          </a:solidFill>
+                          <a:latin typeface="Arial"/>
                         </a:rPr>
                         <a:t>선우다 상용셀</a:t>
                       </a:r>
@@ -4702,12 +4724,23 @@
                     <a:p>
                       <a:pPr algn="l"/>
                       <a:r>
-                        <a:rPr sz="1000" b="1">
-                          <a:solidFill>
-                            <a:srgbClr val="222222"/>
-                          </a:solidFill>
-                          <a:latin typeface="Arial"/>
-                          <a:ea typeface="AppleGothic"/>
+                        <a:rPr sz="850" b="1">
+                          <a:solidFill>
+                            <a:srgbClr val="222222"/>
+                          </a:solidFill>
+                          <a:latin typeface="Arial"/>
+                        </a:rPr>
+                        <a:t>N-CMAPSS</a:t>
+                      </a:r>
+                    </a:p>
+                    <a:p>
+                      <a:pPr algn="l"/>
+                      <a:r>
+                        <a:rPr sz="850" b="1">
+                          <a:solidFill>
+                            <a:srgbClr val="222222"/>
+                          </a:solidFill>
+                          <a:latin typeface="Arial"/>
                         </a:rPr>
                         <a:t>항공기 엔진</a:t>
                       </a:r>
@@ -4776,12 +4809,23 @@
                     <a:p>
                       <a:pPr algn="l"/>
                       <a:r>
-                        <a:rPr sz="1000" b="1">
-                          <a:solidFill>
-                            <a:srgbClr val="222222"/>
-                          </a:solidFill>
-                          <a:latin typeface="Arial"/>
-                          <a:ea typeface="AppleGothic"/>
+                        <a:rPr sz="850" b="1">
+                          <a:solidFill>
+                            <a:srgbClr val="222222"/>
+                          </a:solidFill>
+                          <a:latin typeface="Arial"/>
+                        </a:rPr>
+                        <a:t>Virkler</a:t>
+                      </a:r>
+                    </a:p>
+                    <a:p>
+                      <a:pPr algn="l"/>
+                      <a:r>
+                        <a:rPr sz="850" b="1">
+                          <a:solidFill>
+                            <a:srgbClr val="222222"/>
+                          </a:solidFill>
+                          <a:latin typeface="Arial"/>
                         </a:rPr>
                         <a:t>알루미늄 균열</a:t>
                       </a:r>
@@ -4850,12 +4894,23 @@
                     <a:p>
                       <a:pPr algn="l"/>
                       <a:r>
-                        <a:rPr sz="1000" b="1">
-                          <a:solidFill>
-                            <a:srgbClr val="222222"/>
-                          </a:solidFill>
-                          <a:latin typeface="Arial"/>
-                          <a:ea typeface="AppleGothic"/>
+                        <a:rPr sz="850" b="1">
+                          <a:solidFill>
+                            <a:srgbClr val="222222"/>
+                          </a:solidFill>
+                          <a:latin typeface="Arial"/>
+                        </a:rPr>
+                        <a:t>RWTH</a:t>
+                      </a:r>
+                    </a:p>
+                    <a:p>
+                      <a:pPr algn="l"/>
+                      <a:r>
+                        <a:rPr sz="850" b="1">
+                          <a:solidFill>
+                            <a:srgbClr val="222222"/>
+                          </a:solidFill>
+                          <a:latin typeface="Arial"/>
                         </a:rPr>
                         <a:t>아헨 배터리</a:t>
                       </a:r>
@@ -4924,12 +4979,23 @@
                     <a:p>
                       <a:pPr algn="l"/>
                       <a:r>
-                        <a:rPr sz="1000" b="1">
-                          <a:solidFill>
-                            <a:srgbClr val="222222"/>
-                          </a:solidFill>
-                          <a:latin typeface="Arial"/>
-                          <a:ea typeface="AppleGothic"/>
+                        <a:rPr sz="850" b="1">
+                          <a:solidFill>
+                            <a:srgbClr val="222222"/>
+                          </a:solidFill>
+                          <a:latin typeface="Arial"/>
+                        </a:rPr>
+                        <a:t>MATR batch2</a:t>
+                      </a:r>
+                    </a:p>
+                    <a:p>
+                      <a:pPr algn="l"/>
+                      <a:r>
+                        <a:rPr sz="850" b="1">
+                          <a:solidFill>
+                            <a:srgbClr val="222222"/>
+                          </a:solidFill>
+                          <a:latin typeface="Arial"/>
                         </a:rPr>
                         <a:t>MIT 배치2</a:t>
                       </a:r>
@@ -4998,12 +5064,23 @@
                     <a:p>
                       <a:pPr algn="l"/>
                       <a:r>
-                        <a:rPr sz="1000" b="1">
-                          <a:solidFill>
-                            <a:srgbClr val="222222"/>
-                          </a:solidFill>
-                          <a:latin typeface="Arial"/>
-                          <a:ea typeface="AppleGothic"/>
+                        <a:rPr sz="850" b="1">
+                          <a:solidFill>
+                            <a:srgbClr val="222222"/>
+                          </a:solidFill>
+                          <a:latin typeface="Arial"/>
+                        </a:rPr>
+                        <a:t>MICH</a:t>
+                      </a:r>
+                    </a:p>
+                    <a:p>
+                      <a:pPr algn="l"/>
+                      <a:r>
+                        <a:rPr sz="850" b="1">
+                          <a:solidFill>
+                            <a:srgbClr val="222222"/>
+                          </a:solidFill>
+                          <a:latin typeface="Arial"/>
                         </a:rPr>
                         <a:t>미시간 배터리</a:t>
                       </a:r>
@@ -5072,12 +5149,23 @@
                     <a:p>
                       <a:pPr algn="l"/>
                       <a:r>
-                        <a:rPr sz="1000" b="1">
-                          <a:solidFill>
-                            <a:srgbClr val="222222"/>
-                          </a:solidFill>
-                          <a:latin typeface="Arial"/>
-                          <a:ea typeface="AppleGothic"/>
+                        <a:rPr sz="850" b="1">
+                          <a:solidFill>
+                            <a:srgbClr val="222222"/>
+                          </a:solidFill>
+                          <a:latin typeface="Arial"/>
+                        </a:rPr>
+                        <a:t>NASA PCoE</a:t>
+                      </a:r>
+                    </a:p>
+                    <a:p>
+                      <a:pPr algn="l"/>
+                      <a:r>
+                        <a:rPr sz="850" b="1">
+                          <a:solidFill>
+                            <a:srgbClr val="222222"/>
+                          </a:solidFill>
+                          <a:latin typeface="Arial"/>
                         </a:rPr>
                         <a:t>NASA 실험셀</a:t>
                       </a:r>
@@ -5146,12 +5234,23 @@
                     <a:p>
                       <a:pPr algn="l"/>
                       <a:r>
-                        <a:rPr sz="1000" b="1">
-                          <a:solidFill>
-                            <a:srgbClr val="222222"/>
-                          </a:solidFill>
-                          <a:latin typeface="Arial"/>
-                          <a:ea typeface="AppleGothic"/>
+                        <a:rPr sz="850" b="1">
+                          <a:solidFill>
+                            <a:srgbClr val="222222"/>
+                          </a:solidFill>
+                          <a:latin typeface="Arial"/>
+                        </a:rPr>
+                        <a:t>MATR 2019</a:t>
+                      </a:r>
+                    </a:p>
+                    <a:p>
+                      <a:pPr algn="l"/>
+                      <a:r>
+                        <a:rPr sz="850" b="1">
+                          <a:solidFill>
+                            <a:srgbClr val="222222"/>
+                          </a:solidFill>
+                          <a:latin typeface="Arial"/>
                         </a:rPr>
                         <a:t>MIT 2019</a:t>
                       </a:r>
@@ -8577,1060 +8676,6 @@
 </p:sld>
 </file>
 
-<file path=ppt/slides/slide13.xml><?xml version="1.0" encoding="utf-8"?>
-<p:sld xmlns:a="http://schemas.openxmlformats.org/drawingml/2006/main" xmlns:p="http://schemas.openxmlformats.org/presentationml/2006/main" xmlns:r="http://schemas.openxmlformats.org/officeDocument/2006/relationships">
-  <p:cSld>
-    <p:spTree>
-      <p:nvGrpSpPr>
-        <p:cNvPr id="1" name=""/>
-        <p:cNvGrpSpPr/>
-        <p:nvPr/>
-      </p:nvGrpSpPr>
-      <p:grpSpPr/>
-      <p:sp>
-        <p:nvSpPr>
-          <p:cNvPr id="2" name="Rectangle 1"/>
-          <p:cNvSpPr/>
-          <p:nvPr/>
-        </p:nvSpPr>
-        <p:spPr>
-          <a:xfrm>
-            <a:off x="0" y="0"/>
-            <a:ext cx="12192000" cy="6858000"/>
-          </a:xfrm>
-          <a:prstGeom prst="rect">
-            <a:avLst/>
-          </a:prstGeom>
-          <a:solidFill>
-            <a:srgbClr val="FFFFFF"/>
-          </a:solidFill>
-          <a:ln>
-            <a:noFill/>
-          </a:ln>
-        </p:spPr>
-        <p:style>
-          <a:lnRef idx="1">
-            <a:schemeClr val="accent1"/>
-          </a:lnRef>
-          <a:fillRef idx="3">
-            <a:schemeClr val="accent1"/>
-          </a:fillRef>
-          <a:effectRef idx="2">
-            <a:schemeClr val="accent1"/>
-          </a:effectRef>
-          <a:fontRef idx="minor">
-            <a:schemeClr val="lt1"/>
-          </a:fontRef>
-        </p:style>
-        <p:txBody>
-          <a:bodyPr rtlCol="0" anchor="ctr"/>
-          <a:lstStyle/>
-          <a:p>
-            <a:pPr algn="ctr"/>
-          </a:p>
-        </p:txBody>
-      </p:sp>
-      <p:sp>
-        <p:nvSpPr>
-          <p:cNvPr id="3" name="Rectangle 2"/>
-          <p:cNvSpPr/>
-          <p:nvPr/>
-        </p:nvSpPr>
-        <p:spPr>
-          <a:xfrm>
-            <a:off x="0" y="0"/>
-            <a:ext cx="12192000" cy="19050"/>
-          </a:xfrm>
-          <a:prstGeom prst="rect">
-            <a:avLst/>
-          </a:prstGeom>
-          <a:solidFill>
-            <a:srgbClr val="222222"/>
-          </a:solidFill>
-          <a:ln>
-            <a:noFill/>
-          </a:ln>
-        </p:spPr>
-        <p:style>
-          <a:lnRef idx="1">
-            <a:schemeClr val="accent1"/>
-          </a:lnRef>
-          <a:fillRef idx="3">
-            <a:schemeClr val="accent1"/>
-          </a:fillRef>
-          <a:effectRef idx="2">
-            <a:schemeClr val="accent1"/>
-          </a:effectRef>
-          <a:fontRef idx="minor">
-            <a:schemeClr val="lt1"/>
-          </a:fontRef>
-        </p:style>
-        <p:txBody>
-          <a:bodyPr rtlCol="0" anchor="ctr"/>
-          <a:lstStyle/>
-          <a:p>
-            <a:pPr algn="ctr"/>
-          </a:p>
-        </p:txBody>
-      </p:sp>
-      <p:sp>
-        <p:nvSpPr>
-          <p:cNvPr id="4" name="TextBox 3"/>
-          <p:cNvSpPr txBox="1"/>
-          <p:nvPr/>
-        </p:nvSpPr>
-        <p:spPr>
-          <a:xfrm>
-            <a:off x="457200" y="209550"/>
-            <a:ext cx="11239500" cy="304800"/>
-          </a:xfrm>
-          <a:prstGeom prst="rect">
-            <a:avLst/>
-          </a:prstGeom>
-          <a:noFill/>
-        </p:spPr>
-        <p:txBody>
-          <a:bodyPr wrap="square">
-            <a:spAutoFit/>
-          </a:bodyPr>
-          <a:lstStyle/>
-          <a:p>
-            <a:pPr algn="l"/>
-            <a:r>
-              <a:rPr sz="2200" b="1">
-                <a:solidFill>
-                  <a:srgbClr val="222222"/>
-                </a:solidFill>
-                <a:latin typeface="Arial"/>
-                <a:ea typeface="AppleGothic"/>
-              </a:rPr>
-              <a:t>통계검정 지도 — 질문마다 검정이 다르다</a:t>
-            </a:r>
-          </a:p>
-        </p:txBody>
-      </p:sp>
-      <p:sp>
-        <p:nvSpPr>
-          <p:cNvPr id="5" name="TextBox 4"/>
-          <p:cNvSpPr txBox="1"/>
-          <p:nvPr/>
-        </p:nvSpPr>
-        <p:spPr>
-          <a:xfrm>
-            <a:off x="457200" y="514350"/>
-            <a:ext cx="11239500" cy="190500"/>
-          </a:xfrm>
-          <a:prstGeom prst="rect">
-            <a:avLst/>
-          </a:prstGeom>
-          <a:noFill/>
-        </p:spPr>
-        <p:txBody>
-          <a:bodyPr wrap="square">
-            <a:spAutoFit/>
-          </a:bodyPr>
-          <a:lstStyle/>
-          <a:p>
-            <a:pPr algn="l"/>
-            <a:r>
-              <a:rPr sz="1200" b="0">
-                <a:solidFill>
-                  <a:srgbClr val="666666"/>
-                </a:solidFill>
-                <a:latin typeface="Arial"/>
-                <a:ea typeface="AppleGothic"/>
-              </a:rPr>
-              <a:t>내부 구조·외부 경쟁력·component·붕괴 안정성을 하나의 p값으로 섞지 않는다.</a:t>
-            </a:r>
-          </a:p>
-        </p:txBody>
-      </p:sp>
-      <p:graphicFrame>
-        <p:nvGraphicFramePr>
-          <p:cNvPr id="6" name="Table 5"/>
-          <p:cNvGraphicFramePr>
-            <a:graphicFrameLocks noGrp="1"/>
-          </p:cNvGraphicFramePr>
-          <p:nvPr/>
-        </p:nvGraphicFramePr>
-        <p:xfrm>
-          <a:off x="457200" y="904875"/>
-          <a:ext cx="11277600" cy="3714750"/>
-        </p:xfrm>
-        <a:graphic>
-          <a:graphicData uri="http://schemas.openxmlformats.org/drawingml/2006/table">
-            <a:tbl>
-              <a:tblPr firstRow="1" bandRow="1">
-                <a:tableStyleId>{5C22544A-7EE6-4342-B048-85BDC9FD1C3A}</a:tableStyleId>
-              </a:tblPr>
-              <a:tblGrid>
-                <a:gridCol w="2255520"/>
-                <a:gridCol w="2255520"/>
-                <a:gridCol w="2255520"/>
-                <a:gridCol w="2255520"/>
-                <a:gridCol w="2255520"/>
-              </a:tblGrid>
-              <a:tr h="619125">
-                <a:tc>
-                  <a:txBody>
-                    <a:bodyPr/>
-                    <a:lstStyle/>
-                    <a:p>
-                      <a:pPr algn="ctr"/>
-                      <a:r>
-                        <a:rPr sz="1000" b="1">
-                          <a:solidFill>
-                            <a:srgbClr val="FFFFFF"/>
-                          </a:solidFill>
-                          <a:latin typeface="Arial"/>
-                          <a:ea typeface="AppleGothic"/>
-                        </a:rPr>
-                        <a:t>질문</a:t>
-                      </a:r>
-                    </a:p>
-                  </a:txBody>
-                  <a:tcPr anchor="ctr">
-                    <a:solidFill>
-                      <a:srgbClr val="222222"/>
-                    </a:solidFill>
-                  </a:tcPr>
-                </a:tc>
-                <a:tc>
-                  <a:txBody>
-                    <a:bodyPr/>
-                    <a:lstStyle/>
-                    <a:p>
-                      <a:pPr algn="ctr"/>
-                      <a:r>
-                        <a:rPr sz="1000" b="1">
-                          <a:solidFill>
-                            <a:srgbClr val="FFFFFF"/>
-                          </a:solidFill>
-                          <a:latin typeface="Arial"/>
-                          <a:ea typeface="AppleGothic"/>
-                        </a:rPr>
-                        <a:t>비교 대상</a:t>
-                      </a:r>
-                    </a:p>
-                  </a:txBody>
-                  <a:tcPr anchor="ctr">
-                    <a:solidFill>
-                      <a:srgbClr val="222222"/>
-                    </a:solidFill>
-                  </a:tcPr>
-                </a:tc>
-                <a:tc>
-                  <a:txBody>
-                    <a:bodyPr/>
-                    <a:lstStyle/>
-                    <a:p>
-                      <a:pPr algn="ctr"/>
-                      <a:r>
-                        <a:rPr sz="1000" b="1">
-                          <a:solidFill>
-                            <a:srgbClr val="FFFFFF"/>
-                          </a:solidFill>
-                          <a:latin typeface="Arial"/>
-                          <a:ea typeface="AppleGothic"/>
-                        </a:rPr>
-                        <a:t>표본 단위</a:t>
-                      </a:r>
-                    </a:p>
-                  </a:txBody>
-                  <a:tcPr anchor="ctr">
-                    <a:solidFill>
-                      <a:srgbClr val="222222"/>
-                    </a:solidFill>
-                  </a:tcPr>
-                </a:tc>
-                <a:tc>
-                  <a:txBody>
-                    <a:bodyPr/>
-                    <a:lstStyle/>
-                    <a:p>
-                      <a:pPr algn="ctr"/>
-                      <a:r>
-                        <a:rPr sz="1000" b="1">
-                          <a:solidFill>
-                            <a:srgbClr val="FFFFFF"/>
-                          </a:solidFill>
-                          <a:latin typeface="Arial"/>
-                          <a:ea typeface="AppleGothic"/>
-                        </a:rPr>
-                        <a:t>검정</a:t>
-                      </a:r>
-                    </a:p>
-                  </a:txBody>
-                  <a:tcPr anchor="ctr">
-                    <a:solidFill>
-                      <a:srgbClr val="222222"/>
-                    </a:solidFill>
-                  </a:tcPr>
-                </a:tc>
-                <a:tc>
-                  <a:txBody>
-                    <a:bodyPr/>
-                    <a:lstStyle/>
-                    <a:p>
-                      <a:pPr algn="ctr"/>
-                      <a:r>
-                        <a:rPr sz="1000" b="1">
-                          <a:solidFill>
-                            <a:srgbClr val="FFFFFF"/>
-                          </a:solidFill>
-                          <a:latin typeface="Arial"/>
-                          <a:ea typeface="AppleGothic"/>
-                        </a:rPr>
-                        <a:t>판정</a:t>
-                      </a:r>
-                    </a:p>
-                  </a:txBody>
-                  <a:tcPr anchor="ctr">
-                    <a:solidFill>
-                      <a:srgbClr val="222222"/>
-                    </a:solidFill>
-                  </a:tcPr>
-                </a:tc>
-              </a:tr>
-              <a:tr h="619125">
-                <a:tc>
-                  <a:txBody>
-                    <a:bodyPr/>
-                    <a:lstStyle/>
-                    <a:p>
-                      <a:pPr algn="l"/>
-                      <a:r>
-                        <a:rPr sz="1000" b="1">
-                          <a:solidFill>
-                            <a:srgbClr val="222222"/>
-                          </a:solidFill>
-                          <a:latin typeface="Arial"/>
-                          <a:ea typeface="AppleGothic"/>
-                        </a:rPr>
-                        <a:t>Prior 구조가 필요한가?</a:t>
-                      </a:r>
-                    </a:p>
-                  </a:txBody>
-                  <a:tcPr anchor="ctr">
-                    <a:solidFill>
-                      <a:srgbClr val="FFFFFF"/>
-                    </a:solidFill>
-                  </a:tcPr>
-                </a:tc>
-                <a:tc>
-                  <a:txBody>
-                    <a:bodyPr/>
-                    <a:lstStyle/>
-                    <a:p>
-                      <a:pPr algn="ctr"/>
-                      <a:r>
-                        <a:rPr sz="1000" b="0">
-                          <a:solidFill>
-                            <a:srgbClr val="222222"/>
-                          </a:solidFill>
-                          <a:latin typeface="Arial"/>
-                          <a:ea typeface="AppleGothic"/>
-                        </a:rPr>
-                        <a:t>PP-X vs matched direct</a:t>
-                      </a:r>
-                    </a:p>
-                  </a:txBody>
-                  <a:tcPr anchor="ctr">
-                    <a:solidFill>
-                      <a:srgbClr val="FFFFFF"/>
-                    </a:solidFill>
-                  </a:tcPr>
-                </a:tc>
-                <a:tc>
-                  <a:txBody>
-                    <a:bodyPr/>
-                    <a:lstStyle/>
-                    <a:p>
-                      <a:pPr algn="ctr"/>
-                      <a:r>
-                        <a:rPr sz="1000" b="0">
-                          <a:solidFill>
-                            <a:srgbClr val="222222"/>
-                          </a:solidFill>
-                          <a:latin typeface="Arial"/>
-                          <a:ea typeface="AppleGothic"/>
-                        </a:rPr>
-                        <a:t>9 setting · 77 physical units</a:t>
-                      </a:r>
-                    </a:p>
-                  </a:txBody>
-                  <a:tcPr anchor="ctr">
-                    <a:solidFill>
-                      <a:srgbClr val="FFFFFF"/>
-                    </a:solidFill>
-                  </a:tcPr>
-                </a:tc>
-                <a:tc>
-                  <a:txBody>
-                    <a:bodyPr/>
-                    <a:lstStyle/>
-                    <a:p>
-                      <a:pPr algn="ctr"/>
-                      <a:r>
-                        <a:rPr sz="1000" b="0">
-                          <a:solidFill>
-                            <a:srgbClr val="222222"/>
-                          </a:solidFill>
-                          <a:latin typeface="Arial"/>
-                          <a:ea typeface="AppleGothic"/>
-                        </a:rPr>
-                        <a:t>exact sign + hierarchical bootstrap</a:t>
-                      </a:r>
-                    </a:p>
-                  </a:txBody>
-                  <a:tcPr anchor="ctr">
-                    <a:solidFill>
-                      <a:srgbClr val="FFFFFF"/>
-                    </a:solidFill>
-                  </a:tcPr>
-                </a:tc>
-                <a:tc>
-                  <a:txBody>
-                    <a:bodyPr/>
-                    <a:lstStyle/>
-                    <a:p>
-                      <a:pPr algn="ctr"/>
-                      <a:r>
-                        <a:rPr sz="1000" b="0">
-                          <a:solidFill>
-                            <a:srgbClr val="222222"/>
-                          </a:solidFill>
-                          <a:latin typeface="Arial"/>
-                          <a:ea typeface="AppleGothic"/>
-                        </a:rPr>
-                        <a:t>9/9 · p=.0039 · RMSE −33.8%</a:t>
-                      </a:r>
-                    </a:p>
-                  </a:txBody>
-                  <a:tcPr anchor="ctr">
-                    <a:solidFill>
-                      <a:srgbClr val="FFFFFF"/>
-                    </a:solidFill>
-                  </a:tcPr>
-                </a:tc>
-              </a:tr>
-              <a:tr h="619125">
-                <a:tc>
-                  <a:txBody>
-                    <a:bodyPr/>
-                    <a:lstStyle/>
-                    <a:p>
-                      <a:pPr algn="l"/>
-                      <a:r>
-                        <a:rPr sz="1000" b="1">
-                          <a:solidFill>
-                            <a:srgbClr val="222222"/>
-                          </a:solidFill>
-                          <a:latin typeface="Arial"/>
-                          <a:ea typeface="AppleGothic"/>
-                        </a:rPr>
-                        <a:t>강한 ML보다 경쟁력 있나?</a:t>
-                      </a:r>
-                    </a:p>
-                  </a:txBody>
-                  <a:tcPr anchor="ctr">
-                    <a:solidFill>
-                      <a:srgbClr val="F5F5F5"/>
-                    </a:solidFill>
-                  </a:tcPr>
-                </a:tc>
-                <a:tc>
-                  <a:txBody>
-                    <a:bodyPr/>
-                    <a:lstStyle/>
-                    <a:p>
-                      <a:pPr algn="ctr"/>
-                      <a:r>
-                        <a:rPr sz="1000" b="0">
-                          <a:solidFill>
-                            <a:srgbClr val="222222"/>
-                          </a:solidFill>
-                          <a:latin typeface="Arial"/>
-                          <a:ea typeface="AppleGothic"/>
-                        </a:rPr>
-                        <a:t>PP-X vs 동일예산 최강 baseline</a:t>
-                      </a:r>
-                    </a:p>
-                  </a:txBody>
-                  <a:tcPr anchor="ctr">
-                    <a:solidFill>
-                      <a:srgbClr val="F5F5F5"/>
-                    </a:solidFill>
-                  </a:tcPr>
-                </a:tc>
-                <a:tc>
-                  <a:txBody>
-                    <a:bodyPr/>
-                    <a:lstStyle/>
-                    <a:p>
-                      <a:pPr algn="ctr"/>
-                      <a:r>
-                        <a:rPr sz="1000" b="0">
-                          <a:solidFill>
-                            <a:srgbClr val="222222"/>
-                          </a:solidFill>
-                          <a:latin typeface="Arial"/>
-                          <a:ea typeface="AppleGothic"/>
-                        </a:rPr>
-                        <a:t>9 settings</a:t>
-                      </a:r>
-                    </a:p>
-                  </a:txBody>
-                  <a:tcPr anchor="ctr">
-                    <a:solidFill>
-                      <a:srgbClr val="F5F5F5"/>
-                    </a:solidFill>
-                  </a:tcPr>
-                </a:tc>
-                <a:tc>
-                  <a:txBody>
-                    <a:bodyPr/>
-                    <a:lstStyle/>
-                    <a:p>
-                      <a:pPr algn="ctr"/>
-                      <a:r>
-                        <a:rPr sz="1000" b="0">
-                          <a:solidFill>
-                            <a:srgbClr val="222222"/>
-                          </a:solidFill>
-                          <a:latin typeface="Arial"/>
-                          <a:ea typeface="AppleGothic"/>
-                        </a:rPr>
-                        <a:t>two-sided exact sign</a:t>
-                      </a:r>
-                    </a:p>
-                  </a:txBody>
-                  <a:tcPr anchor="ctr">
-                    <a:solidFill>
-                      <a:srgbClr val="F5F5F5"/>
-                    </a:solidFill>
-                  </a:tcPr>
-                </a:tc>
-                <a:tc>
-                  <a:txBody>
-                    <a:bodyPr/>
-                    <a:lstStyle/>
-                    <a:p>
-                      <a:pPr algn="ctr"/>
-                      <a:r>
-                        <a:rPr sz="1000" b="0">
-                          <a:solidFill>
-                            <a:srgbClr val="222222"/>
-                          </a:solidFill>
-                          <a:latin typeface="Arial"/>
-                          <a:ea typeface="AppleGothic"/>
-                        </a:rPr>
-                        <a:t>8/9 · p=.0391</a:t>
-                      </a:r>
-                    </a:p>
-                  </a:txBody>
-                  <a:tcPr anchor="ctr">
-                    <a:solidFill>
-                      <a:srgbClr val="F5F5F5"/>
-                    </a:solidFill>
-                  </a:tcPr>
-                </a:tc>
-              </a:tr>
-              <a:tr h="619125">
-                <a:tc>
-                  <a:txBody>
-                    <a:bodyPr/>
-                    <a:lstStyle/>
-                    <a:p>
-                      <a:pPr algn="l"/>
-                      <a:r>
-                        <a:rPr sz="1000" b="1">
-                          <a:solidFill>
-                            <a:srgbClr val="222222"/>
-                          </a:solidFill>
-                          <a:latin typeface="Arial"/>
-                          <a:ea typeface="AppleGothic"/>
-                        </a:rPr>
-                        <a:t>각 module이 필요한가?</a:t>
-                      </a:r>
-                    </a:p>
-                  </a:txBody>
-                  <a:tcPr anchor="ctr">
-                    <a:solidFill>
-                      <a:srgbClr val="FFFFFF"/>
-                    </a:solidFill>
-                  </a:tcPr>
-                </a:tc>
-                <a:tc>
-                  <a:txBody>
-                    <a:bodyPr/>
-                    <a:lstStyle/>
-                    <a:p>
-                      <a:pPr algn="ctr"/>
-                      <a:r>
-                        <a:rPr sz="1000" b="0">
-                          <a:solidFill>
-                            <a:srgbClr val="222222"/>
-                          </a:solidFill>
-                          <a:latin typeface="Arial"/>
-                          <a:ea typeface="AppleGothic"/>
-                        </a:rPr>
-                        <a:t>component on vs off</a:t>
-                      </a:r>
-                    </a:p>
-                  </a:txBody>
-                  <a:tcPr anchor="ctr">
-                    <a:solidFill>
-                      <a:srgbClr val="FFFFFF"/>
-                    </a:solidFill>
-                  </a:tcPr>
-                </a:tc>
-                <a:tc>
-                  <a:txBody>
-                    <a:bodyPr/>
-                    <a:lstStyle/>
-                    <a:p>
-                      <a:pPr algn="ctr"/>
-                      <a:r>
-                        <a:rPr sz="1000" b="0">
-                          <a:solidFill>
-                            <a:srgbClr val="222222"/>
-                          </a:solidFill>
-                          <a:latin typeface="Arial"/>
-                          <a:ea typeface="AppleGothic"/>
-                        </a:rPr>
-                        <a:t>physical units</a:t>
-                      </a:r>
-                    </a:p>
-                  </a:txBody>
-                  <a:tcPr anchor="ctr">
-                    <a:solidFill>
-                      <a:srgbClr val="FFFFFF"/>
-                    </a:solidFill>
-                  </a:tcPr>
-                </a:tc>
-                <a:tc>
-                  <a:txBody>
-                    <a:bodyPr/>
-                    <a:lstStyle/>
-                    <a:p>
-                      <a:pPr algn="ctr"/>
-                      <a:r>
-                        <a:rPr sz="1000" b="0">
-                          <a:solidFill>
-                            <a:srgbClr val="222222"/>
-                          </a:solidFill>
-                          <a:latin typeface="Arial"/>
-                          <a:ea typeface="AppleGothic"/>
-                        </a:rPr>
-                        <a:t>unit sign/boot + 24개 BH</a:t>
-                      </a:r>
-                    </a:p>
-                  </a:txBody>
-                  <a:tcPr anchor="ctr">
-                    <a:solidFill>
-                      <a:srgbClr val="FFFFFF"/>
-                    </a:solidFill>
-                  </a:tcPr>
-                </a:tc>
-                <a:tc>
-                  <a:txBody>
-                    <a:bodyPr/>
-                    <a:lstStyle/>
-                    <a:p>
-                      <a:pPr algn="ctr"/>
-                      <a:r>
-                        <a:rPr sz="1000" b="0">
-                          <a:solidFill>
-                            <a:srgbClr val="222222"/>
-                          </a:solidFill>
-                          <a:latin typeface="Arial"/>
-                          <a:ea typeface="AppleGothic"/>
-                        </a:rPr>
-                        <a:t>일부 개선·일부 악화 유의</a:t>
-                      </a:r>
-                    </a:p>
-                  </a:txBody>
-                  <a:tcPr anchor="ctr">
-                    <a:solidFill>
-                      <a:srgbClr val="FFFFFF"/>
-                    </a:solidFill>
-                  </a:tcPr>
-                </a:tc>
-              </a:tr>
-              <a:tr h="619125">
-                <a:tc>
-                  <a:txBody>
-                    <a:bodyPr/>
-                    <a:lstStyle/>
-                    <a:p>
-                      <a:pPr algn="l"/>
-                      <a:r>
-                        <a:rPr sz="1000" b="1">
-                          <a:solidFill>
-                            <a:srgbClr val="222222"/>
-                          </a:solidFill>
-                          <a:latin typeface="Arial"/>
-                          <a:ea typeface="AppleGothic"/>
-                        </a:rPr>
-                        <a:t>외삽이 덜 무너지나?</a:t>
-                      </a:r>
-                    </a:p>
-                  </a:txBody>
-                  <a:tcPr anchor="ctr">
-                    <a:solidFill>
-                      <a:srgbClr val="F5F5F5"/>
-                    </a:solidFill>
-                  </a:tcPr>
-                </a:tc>
-                <a:tc>
-                  <a:txBody>
-                    <a:bodyPr/>
-                    <a:lstStyle/>
-                    <a:p>
-                      <a:pPr algn="ctr"/>
-                      <a:r>
-                        <a:rPr sz="1000" b="0">
-                          <a:solidFill>
-                            <a:srgbClr val="222222"/>
-                          </a:solidFill>
-                          <a:latin typeface="Arial"/>
-                          <a:ea typeface="AppleGothic"/>
-                        </a:rPr>
-                        <a:t>9모델의 setting별 R² 분포</a:t>
-                      </a:r>
-                    </a:p>
-                  </a:txBody>
-                  <a:tcPr anchor="ctr">
-                    <a:solidFill>
-                      <a:srgbClr val="F5F5F5"/>
-                    </a:solidFill>
-                  </a:tcPr>
-                </a:tc>
-                <a:tc>
-                  <a:txBody>
-                    <a:bodyPr/>
-                    <a:lstStyle/>
-                    <a:p>
-                      <a:pPr algn="ctr"/>
-                      <a:r>
-                        <a:rPr sz="1000" b="0">
-                          <a:solidFill>
-                            <a:srgbClr val="222222"/>
-                          </a:solidFill>
-                          <a:latin typeface="Arial"/>
-                          <a:ea typeface="AppleGothic"/>
-                        </a:rPr>
-                        <a:t>9 settings</a:t>
-                      </a:r>
-                    </a:p>
-                  </a:txBody>
-                  <a:tcPr anchor="ctr">
-                    <a:solidFill>
-                      <a:srgbClr val="F5F5F5"/>
-                    </a:solidFill>
-                  </a:tcPr>
-                </a:tc>
-                <a:tc>
-                  <a:txBody>
-                    <a:bodyPr/>
-                    <a:lstStyle/>
-                    <a:p>
-                      <a:pPr algn="ctr"/>
-                      <a:r>
-                        <a:rPr sz="1000" b="0">
-                          <a:solidFill>
-                            <a:srgbClr val="222222"/>
-                          </a:solidFill>
-                          <a:latin typeface="Arial"/>
-                          <a:ea typeface="AppleGothic"/>
-                        </a:rPr>
-                        <a:t>MAD permutation + SD bootstrap</a:t>
-                      </a:r>
-                    </a:p>
-                  </a:txBody>
-                  <a:tcPr anchor="ctr">
-                    <a:solidFill>
-                      <a:srgbClr val="F5F5F5"/>
-                    </a:solidFill>
-                  </a:tcPr>
-                </a:tc>
-                <a:tc>
-                  <a:txBody>
-                    <a:bodyPr/>
-                    <a:lstStyle/>
-                    <a:p>
-                      <a:pPr algn="ctr"/>
-                      <a:r>
-                        <a:rPr sz="1000" b="0">
-                          <a:solidFill>
-                            <a:srgbClr val="222222"/>
-                          </a:solidFill>
-                          <a:latin typeface="Arial"/>
-                          <a:ea typeface="AppleGothic"/>
-                        </a:rPr>
-                        <a:t>관찰상 우수; Holm 후 전역 비유의</a:t>
-                      </a:r>
-                    </a:p>
-                  </a:txBody>
-                  <a:tcPr anchor="ctr">
-                    <a:solidFill>
-                      <a:srgbClr val="F5F5F5"/>
-                    </a:solidFill>
-                  </a:tcPr>
-                </a:tc>
-              </a:tr>
-              <a:tr h="619125">
-                <a:tc>
-                  <a:txBody>
-                    <a:bodyPr/>
-                    <a:lstStyle/>
-                    <a:p>
-                      <a:pPr algn="l"/>
-                      <a:r>
-                        <a:rPr sz="1000" b="1">
-                          <a:solidFill>
-                            <a:srgbClr val="222222"/>
-                          </a:solidFill>
-                          <a:latin typeface="Arial"/>
-                          <a:ea typeface="AppleGothic"/>
-                        </a:rPr>
-                        <a:t>Seed가 더 안정적인가?</a:t>
-                      </a:r>
-                    </a:p>
-                  </a:txBody>
-                  <a:tcPr anchor="ctr">
-                    <a:solidFill>
-                      <a:srgbClr val="FFFFFF"/>
-                    </a:solidFill>
-                  </a:tcPr>
-                </a:tc>
-                <a:tc>
-                  <a:txBody>
-                    <a:bodyPr/>
-                    <a:lstStyle/>
-                    <a:p>
-                      <a:pPr algn="ctr"/>
-                      <a:r>
-                        <a:rPr sz="1000" b="0">
-                          <a:solidFill>
-                            <a:srgbClr val="222222"/>
-                          </a:solidFill>
-                          <a:latin typeface="Arial"/>
-                          <a:ea typeface="AppleGothic"/>
-                        </a:rPr>
-                        <a:t>5-seed refits</a:t>
-                      </a:r>
-                    </a:p>
-                  </a:txBody>
-                  <a:tcPr anchor="ctr">
-                    <a:solidFill>
-                      <a:srgbClr val="FFFFFF"/>
-                    </a:solidFill>
-                  </a:tcPr>
-                </a:tc>
-                <a:tc>
-                  <a:txBody>
-                    <a:bodyPr/>
-                    <a:lstStyle/>
-                    <a:p>
-                      <a:pPr algn="ctr"/>
-                      <a:r>
-                        <a:rPr sz="1000" b="0">
-                          <a:solidFill>
-                            <a:srgbClr val="222222"/>
-                          </a:solidFill>
-                          <a:latin typeface="Arial"/>
-                          <a:ea typeface="AppleGothic"/>
-                        </a:rPr>
-                        <a:t>optimizer seeds 5개</a:t>
-                      </a:r>
-                    </a:p>
-                  </a:txBody>
-                  <a:tcPr anchor="ctr">
-                    <a:solidFill>
-                      <a:srgbClr val="FFFFFF"/>
-                    </a:solidFill>
-                  </a:tcPr>
-                </a:tc>
-                <a:tc>
-                  <a:txBody>
-                    <a:bodyPr/>
-                    <a:lstStyle/>
-                    <a:p>
-                      <a:pPr algn="ctr"/>
-                      <a:r>
-                        <a:rPr sz="1000" b="0">
-                          <a:solidFill>
-                            <a:srgbClr val="222222"/>
-                          </a:solidFill>
-                          <a:latin typeface="Arial"/>
-                          <a:ea typeface="AppleGothic"/>
-                        </a:rPr>
-                        <a:t>exact sign/기술통계</a:t>
-                      </a:r>
-                    </a:p>
-                  </a:txBody>
-                  <a:tcPr anchor="ctr">
-                    <a:solidFill>
-                      <a:srgbClr val="FFFFFF"/>
-                    </a:solidFill>
-                  </a:tcPr>
-                </a:tc>
-                <a:tc>
-                  <a:txBody>
-                    <a:bodyPr/>
-                    <a:lstStyle/>
-                    <a:p>
-                      <a:pPr algn="ctr"/>
-                      <a:r>
-                        <a:rPr sz="1000" b="0">
-                          <a:solidFill>
-                            <a:srgbClr val="222222"/>
-                          </a:solidFill>
-                          <a:latin typeface="Arial"/>
-                          <a:ea typeface="AppleGothic"/>
-                        </a:rPr>
-                        <a:t>p&lt;.05 확증 불가</a:t>
-                      </a:r>
-                    </a:p>
-                  </a:txBody>
-                  <a:tcPr anchor="ctr">
-                    <a:solidFill>
-                      <a:srgbClr val="FFFFFF"/>
-                    </a:solidFill>
-                  </a:tcPr>
-                </a:tc>
-              </a:tr>
-            </a:tbl>
-          </a:graphicData>
-        </a:graphic>
-      </p:graphicFrame>
-      <p:sp>
-        <p:nvSpPr>
-          <p:cNvPr id="7" name="Rectangle 6"/>
-          <p:cNvSpPr/>
-          <p:nvPr/>
-        </p:nvSpPr>
-        <p:spPr>
-          <a:xfrm>
-            <a:off x="1143000" y="5000625"/>
-            <a:ext cx="9906000" cy="685800"/>
-          </a:xfrm>
-          <a:prstGeom prst="rect">
-            <a:avLst/>
-          </a:prstGeom>
-          <a:solidFill>
-            <a:srgbClr val="E8F1F8"/>
-          </a:solidFill>
-          <a:ln w="15875">
-            <a:solidFill>
-              <a:srgbClr val="0072B2"/>
-            </a:solidFill>
-          </a:ln>
-        </p:spPr>
-        <p:style>
-          <a:lnRef idx="1">
-            <a:schemeClr val="accent1"/>
-          </a:lnRef>
-          <a:fillRef idx="3">
-            <a:schemeClr val="accent1"/>
-          </a:fillRef>
-          <a:effectRef idx="2">
-            <a:schemeClr val="accent1"/>
-          </a:effectRef>
-          <a:fontRef idx="minor">
-            <a:schemeClr val="lt1"/>
-          </a:fontRef>
-        </p:style>
-        <p:txBody>
-          <a:bodyPr rtlCol="0" anchor="ctr"/>
-          <a:lstStyle/>
-          <a:p>
-            <a:pPr algn="ctr"/>
-          </a:p>
-        </p:txBody>
-      </p:sp>
-      <p:sp>
-        <p:nvSpPr>
-          <p:cNvPr id="8" name="TextBox 7"/>
-          <p:cNvSpPr txBox="1"/>
-          <p:nvPr/>
-        </p:nvSpPr>
-        <p:spPr>
-          <a:xfrm>
-            <a:off x="1333500" y="5124450"/>
-            <a:ext cx="9525000" cy="438150"/>
-          </a:xfrm>
-          <a:prstGeom prst="rect">
-            <a:avLst/>
-          </a:prstGeom>
-          <a:noFill/>
-        </p:spPr>
-        <p:txBody>
-          <a:bodyPr wrap="square">
-            <a:spAutoFit/>
-          </a:bodyPr>
-          <a:lstStyle/>
-          <a:p>
-            <a:pPr algn="ctr"/>
-            <a:r>
-              <a:rPr sz="1200" b="1">
-                <a:solidFill>
-                  <a:srgbClr val="222222"/>
-                </a:solidFill>
-                <a:latin typeface="Arial"/>
-                <a:ea typeface="AppleGothic"/>
-              </a:rPr>
-              <a:t>핵심 주장: 현재 9개 retrospective 외삽 setting에서 PP-X는 prior 없는 direct보다 평균 오차가 작고, 강한 동일예산 비교군보다 8/9에서 높으며, 심한 음의 R² 붕괴가 덜 관찰됐다.</a:t>
-            </a:r>
-          </a:p>
-        </p:txBody>
-      </p:sp>
-      <p:sp>
-        <p:nvSpPr>
-          <p:cNvPr id="9" name="TextBox 8"/>
-          <p:cNvSpPr txBox="1"/>
-          <p:nvPr/>
-        </p:nvSpPr>
-        <p:spPr>
-          <a:xfrm>
-            <a:off x="10858500" y="6419850"/>
-            <a:ext cx="838200" cy="171450"/>
-          </a:xfrm>
-          <a:prstGeom prst="rect">
-            <a:avLst/>
-          </a:prstGeom>
-          <a:noFill/>
-        </p:spPr>
-        <p:txBody>
-          <a:bodyPr wrap="square">
-            <a:spAutoFit/>
-          </a:bodyPr>
-          <a:lstStyle/>
-          <a:p>
-            <a:pPr algn="r"/>
-            <a:r>
-              <a:rPr sz="900" b="1">
-                <a:solidFill>
-                  <a:srgbClr val="666666"/>
-                </a:solidFill>
-                <a:latin typeface="Arial"/>
-                <a:ea typeface="AppleGothic"/>
-              </a:rPr>
-              <a:t>13/18</a:t>
-            </a:r>
-          </a:p>
-        </p:txBody>
-      </p:sp>
-    </p:spTree>
-  </p:cSld>
-  <p:clrMapOvr>
-    <a:masterClrMapping/>
-  </p:clrMapOvr>
-</p:sld>
-</file>
-
 <file path=ppt/slides/slide14.xml><?xml version="1.0" encoding="utf-8"?>
 <p:sld xmlns:a="http://schemas.openxmlformats.org/drawingml/2006/main" xmlns:p="http://schemas.openxmlformats.org/presentationml/2006/main" xmlns:r="http://schemas.openxmlformats.org/officeDocument/2006/relationships">
   <p:cSld>
@@ -10641,1665 +9686,6 @@
                 <a:ea typeface="AppleGothic"/>
               </a:rPr>
               <a:t>14/18</a:t>
-            </a:r>
-          </a:p>
-        </p:txBody>
-      </p:sp>
-    </p:spTree>
-  </p:cSld>
-  <p:clrMapOvr>
-    <a:masterClrMapping/>
-  </p:clrMapOvr>
-</p:sld>
-</file>
-
-<file path=ppt/slides/slide15.xml><?xml version="1.0" encoding="utf-8"?>
-<p:sld xmlns:a="http://schemas.openxmlformats.org/drawingml/2006/main" xmlns:p="http://schemas.openxmlformats.org/presentationml/2006/main" xmlns:r="http://schemas.openxmlformats.org/officeDocument/2006/relationships">
-  <p:cSld>
-    <p:spTree>
-      <p:nvGrpSpPr>
-        <p:cNvPr id="1" name=""/>
-        <p:cNvGrpSpPr/>
-        <p:nvPr/>
-      </p:nvGrpSpPr>
-      <p:grpSpPr/>
-      <p:sp>
-        <p:nvSpPr>
-          <p:cNvPr id="2" name="Rectangle 1"/>
-          <p:cNvSpPr/>
-          <p:nvPr/>
-        </p:nvSpPr>
-        <p:spPr>
-          <a:xfrm>
-            <a:off x="0" y="0"/>
-            <a:ext cx="12192000" cy="6858000"/>
-          </a:xfrm>
-          <a:prstGeom prst="rect">
-            <a:avLst/>
-          </a:prstGeom>
-          <a:solidFill>
-            <a:srgbClr val="FFFFFF"/>
-          </a:solidFill>
-          <a:ln>
-            <a:noFill/>
-          </a:ln>
-        </p:spPr>
-        <p:style>
-          <a:lnRef idx="1">
-            <a:schemeClr val="accent1"/>
-          </a:lnRef>
-          <a:fillRef idx="3">
-            <a:schemeClr val="accent1"/>
-          </a:fillRef>
-          <a:effectRef idx="2">
-            <a:schemeClr val="accent1"/>
-          </a:effectRef>
-          <a:fontRef idx="minor">
-            <a:schemeClr val="lt1"/>
-          </a:fontRef>
-        </p:style>
-        <p:txBody>
-          <a:bodyPr rtlCol="0" anchor="ctr"/>
-          <a:lstStyle/>
-          <a:p>
-            <a:pPr algn="ctr"/>
-          </a:p>
-        </p:txBody>
-      </p:sp>
-      <p:sp>
-        <p:nvSpPr>
-          <p:cNvPr id="3" name="Rectangle 2"/>
-          <p:cNvSpPr/>
-          <p:nvPr/>
-        </p:nvSpPr>
-        <p:spPr>
-          <a:xfrm>
-            <a:off x="0" y="0"/>
-            <a:ext cx="12192000" cy="19050"/>
-          </a:xfrm>
-          <a:prstGeom prst="rect">
-            <a:avLst/>
-          </a:prstGeom>
-          <a:solidFill>
-            <a:srgbClr val="222222"/>
-          </a:solidFill>
-          <a:ln>
-            <a:noFill/>
-          </a:ln>
-        </p:spPr>
-        <p:style>
-          <a:lnRef idx="1">
-            <a:schemeClr val="accent1"/>
-          </a:lnRef>
-          <a:fillRef idx="3">
-            <a:schemeClr val="accent1"/>
-          </a:fillRef>
-          <a:effectRef idx="2">
-            <a:schemeClr val="accent1"/>
-          </a:effectRef>
-          <a:fontRef idx="minor">
-            <a:schemeClr val="lt1"/>
-          </a:fontRef>
-        </p:style>
-        <p:txBody>
-          <a:bodyPr rtlCol="0" anchor="ctr"/>
-          <a:lstStyle/>
-          <a:p>
-            <a:pPr algn="ctr"/>
-          </a:p>
-        </p:txBody>
-      </p:sp>
-      <p:sp>
-        <p:nvSpPr>
-          <p:cNvPr id="4" name="TextBox 3"/>
-          <p:cNvSpPr txBox="1"/>
-          <p:nvPr/>
-        </p:nvSpPr>
-        <p:spPr>
-          <a:xfrm>
-            <a:off x="457200" y="209550"/>
-            <a:ext cx="11239500" cy="304800"/>
-          </a:xfrm>
-          <a:prstGeom prst="rect">
-            <a:avLst/>
-          </a:prstGeom>
-          <a:noFill/>
-        </p:spPr>
-        <p:txBody>
-          <a:bodyPr wrap="square">
-            <a:spAutoFit/>
-          </a:bodyPr>
-          <a:lstStyle/>
-          <a:p>
-            <a:pPr algn="l"/>
-            <a:r>
-              <a:rPr sz="2200" b="1">
-                <a:solidFill>
-                  <a:srgbClr val="222222"/>
-                </a:solidFill>
-                <a:latin typeface="Arial"/>
-                <a:ea typeface="AppleGothic"/>
-              </a:rPr>
-              <a:t>검정 2 — 동일예산 강력 baseline과의 외부 경쟁력</a:t>
-            </a:r>
-          </a:p>
-        </p:txBody>
-      </p:sp>
-      <p:sp>
-        <p:nvSpPr>
-          <p:cNvPr id="5" name="TextBox 4"/>
-          <p:cNvSpPr txBox="1"/>
-          <p:nvPr/>
-        </p:nvSpPr>
-        <p:spPr>
-          <a:xfrm>
-            <a:off x="457200" y="514350"/>
-            <a:ext cx="11239500" cy="190500"/>
-          </a:xfrm>
-          <a:prstGeom prst="rect">
-            <a:avLst/>
-          </a:prstGeom>
-          <a:noFill/>
-        </p:spPr>
-        <p:txBody>
-          <a:bodyPr wrap="square">
-            <a:spAutoFit/>
-          </a:bodyPr>
-          <a:lstStyle/>
-          <a:p>
-            <a:pPr algn="l"/>
-            <a:r>
-              <a:rPr sz="1200" b="0">
-                <a:solidFill>
-                  <a:srgbClr val="666666"/>
-                </a:solidFill>
-                <a:latin typeface="Arial"/>
-                <a:ea typeface="AppleGothic"/>
-              </a:rPr>
-              <a:t>각 setting에서 30개 후보를 탐색한 가장 강한 baseline과 PP-X Final을 비교한다.</a:t>
-            </a:r>
-          </a:p>
-        </p:txBody>
-      </p:sp>
-      <p:graphicFrame>
-        <p:nvGraphicFramePr>
-          <p:cNvPr id="6" name="Table 5"/>
-          <p:cNvGraphicFramePr>
-            <a:graphicFrameLocks noGrp="1"/>
-          </p:cNvGraphicFramePr>
-          <p:nvPr/>
-        </p:nvGraphicFramePr>
-        <p:xfrm>
-          <a:off x="457200" y="876300"/>
-          <a:ext cx="11277600" cy="3619500"/>
-        </p:xfrm>
-        <a:graphic>
-          <a:graphicData uri="http://schemas.openxmlformats.org/drawingml/2006/table">
-            <a:tbl>
-              <a:tblPr firstRow="1" bandRow="1">
-                <a:tableStyleId>{5C22544A-7EE6-4342-B048-85BDC9FD1C3A}</a:tableStyleId>
-              </a:tblPr>
-              <a:tblGrid>
-                <a:gridCol w="2255520"/>
-                <a:gridCol w="2255520"/>
-                <a:gridCol w="2255520"/>
-                <a:gridCol w="2255520"/>
-                <a:gridCol w="2255520"/>
-              </a:tblGrid>
-              <a:tr h="361950">
-                <a:tc>
-                  <a:txBody>
-                    <a:bodyPr/>
-                    <a:lstStyle/>
-                    <a:p>
-                      <a:pPr algn="ctr"/>
-                      <a:r>
-                        <a:rPr sz="1000" b="1">
-                          <a:solidFill>
-                            <a:srgbClr val="FFFFFF"/>
-                          </a:solidFill>
-                          <a:latin typeface="Arial"/>
-                          <a:ea typeface="AppleGothic"/>
-                        </a:rPr>
-                        <a:t>Setting</a:t>
-                      </a:r>
-                    </a:p>
-                  </a:txBody>
-                  <a:tcPr anchor="ctr">
-                    <a:solidFill>
-                      <a:srgbClr val="222222"/>
-                    </a:solidFill>
-                  </a:tcPr>
-                </a:tc>
-                <a:tc>
-                  <a:txBody>
-                    <a:bodyPr/>
-                    <a:lstStyle/>
-                    <a:p>
-                      <a:pPr algn="ctr"/>
-                      <a:r>
-                        <a:rPr sz="1000" b="1">
-                          <a:solidFill>
-                            <a:srgbClr val="FFFFFF"/>
-                          </a:solidFill>
-                          <a:latin typeface="Arial"/>
-                          <a:ea typeface="AppleGothic"/>
-                        </a:rPr>
-                        <a:t>PP-X</a:t>
-                      </a:r>
-                    </a:p>
-                  </a:txBody>
-                  <a:tcPr anchor="ctr">
-                    <a:solidFill>
-                      <a:srgbClr val="222222"/>
-                    </a:solidFill>
-                  </a:tcPr>
-                </a:tc>
-                <a:tc>
-                  <a:txBody>
-                    <a:bodyPr/>
-                    <a:lstStyle/>
-                    <a:p>
-                      <a:pPr algn="ctr"/>
-                      <a:r>
-                        <a:rPr sz="1000" b="1">
-                          <a:solidFill>
-                            <a:srgbClr val="FFFFFF"/>
-                          </a:solidFill>
-                          <a:latin typeface="Arial"/>
-                          <a:ea typeface="AppleGothic"/>
-                        </a:rPr>
-                        <a:t>동일예산 최강 baseline</a:t>
-                      </a:r>
-                    </a:p>
-                  </a:txBody>
-                  <a:tcPr anchor="ctr">
-                    <a:solidFill>
-                      <a:srgbClr val="222222"/>
-                    </a:solidFill>
-                  </a:tcPr>
-                </a:tc>
-                <a:tc>
-                  <a:txBody>
-                    <a:bodyPr/>
-                    <a:lstStyle/>
-                    <a:p>
-                      <a:pPr algn="ctr"/>
-                      <a:r>
-                        <a:rPr sz="1000" b="1">
-                          <a:solidFill>
-                            <a:srgbClr val="FFFFFF"/>
-                          </a:solidFill>
-                          <a:latin typeface="Arial"/>
-                          <a:ea typeface="AppleGothic"/>
-                        </a:rPr>
-                        <a:t>차이</a:t>
-                      </a:r>
-                    </a:p>
-                  </a:txBody>
-                  <a:tcPr anchor="ctr">
-                    <a:solidFill>
-                      <a:srgbClr val="222222"/>
-                    </a:solidFill>
-                  </a:tcPr>
-                </a:tc>
-                <a:tc>
-                  <a:txBody>
-                    <a:bodyPr/>
-                    <a:lstStyle/>
-                    <a:p>
-                      <a:pPr algn="ctr"/>
-                      <a:r>
-                        <a:rPr sz="1000" b="1">
-                          <a:solidFill>
-                            <a:srgbClr val="FFFFFF"/>
-                          </a:solidFill>
-                          <a:latin typeface="Arial"/>
-                          <a:ea typeface="AppleGothic"/>
-                        </a:rPr>
-                        <a:t>승패</a:t>
-                      </a:r>
-                    </a:p>
-                  </a:txBody>
-                  <a:tcPr anchor="ctr">
-                    <a:solidFill>
-                      <a:srgbClr val="222222"/>
-                    </a:solidFill>
-                  </a:tcPr>
-                </a:tc>
-              </a:tr>
-              <a:tr h="361950">
-                <a:tc>
-                  <a:txBody>
-                    <a:bodyPr/>
-                    <a:lstStyle/>
-                    <a:p>
-                      <a:pPr algn="l"/>
-                      <a:r>
-                        <a:rPr sz="1000" b="1">
-                          <a:solidFill>
-                            <a:srgbClr val="222222"/>
-                          </a:solidFill>
-                          <a:latin typeface="Arial"/>
-                          <a:ea typeface="AppleGothic"/>
-                        </a:rPr>
-                        <a:t>HUST</a:t>
-                      </a:r>
-                    </a:p>
-                  </a:txBody>
-                  <a:tcPr anchor="ctr">
-                    <a:solidFill>
-                      <a:srgbClr val="FFFFFF"/>
-                    </a:solidFill>
-                  </a:tcPr>
-                </a:tc>
-                <a:tc>
-                  <a:txBody>
-                    <a:bodyPr/>
-                    <a:lstStyle/>
-                    <a:p>
-                      <a:pPr algn="ctr"/>
-                      <a:r>
-                        <a:rPr sz="1000" b="0">
-                          <a:solidFill>
-                            <a:srgbClr val="222222"/>
-                          </a:solidFill>
-                          <a:latin typeface="Arial"/>
-                          <a:ea typeface="AppleGothic"/>
-                        </a:rPr>
-                        <a:t>.958</a:t>
-                      </a:r>
-                    </a:p>
-                  </a:txBody>
-                  <a:tcPr anchor="ctr">
-                    <a:solidFill>
-                      <a:srgbClr val="FFFFFF"/>
-                    </a:solidFill>
-                  </a:tcPr>
-                </a:tc>
-                <a:tc>
-                  <a:txBody>
-                    <a:bodyPr/>
-                    <a:lstStyle/>
-                    <a:p>
-                      <a:pPr algn="ctr"/>
-                      <a:r>
-                        <a:rPr sz="1000" b="0">
-                          <a:solidFill>
-                            <a:srgbClr val="222222"/>
-                          </a:solidFill>
-                          <a:latin typeface="Arial"/>
-                          <a:ea typeface="AppleGothic"/>
-                        </a:rPr>
-                        <a:t>GroupDRO .955</a:t>
-                      </a:r>
-                    </a:p>
-                  </a:txBody>
-                  <a:tcPr anchor="ctr">
-                    <a:solidFill>
-                      <a:srgbClr val="FFFFFF"/>
-                    </a:solidFill>
-                  </a:tcPr>
-                </a:tc>
-                <a:tc>
-                  <a:txBody>
-                    <a:bodyPr/>
-                    <a:lstStyle/>
-                    <a:p>
-                      <a:pPr algn="ctr"/>
-                      <a:r>
-                        <a:rPr sz="1000" b="0">
-                          <a:solidFill>
-                            <a:srgbClr val="222222"/>
-                          </a:solidFill>
-                          <a:latin typeface="Arial"/>
-                          <a:ea typeface="AppleGothic"/>
-                        </a:rPr>
-                        <a:t>+.003</a:t>
-                      </a:r>
-                    </a:p>
-                  </a:txBody>
-                  <a:tcPr anchor="ctr">
-                    <a:solidFill>
-                      <a:srgbClr val="FFFFFF"/>
-                    </a:solidFill>
-                  </a:tcPr>
-                </a:tc>
-                <a:tc>
-                  <a:txBody>
-                    <a:bodyPr/>
-                    <a:lstStyle/>
-                    <a:p>
-                      <a:pPr algn="ctr"/>
-                      <a:r>
-                        <a:rPr sz="1000" b="0">
-                          <a:solidFill>
-                            <a:srgbClr val="222222"/>
-                          </a:solidFill>
-                          <a:latin typeface="Arial"/>
-                          <a:ea typeface="AppleGothic"/>
-                        </a:rPr>
-                        <a:t>승</a:t>
-                      </a:r>
-                    </a:p>
-                  </a:txBody>
-                  <a:tcPr anchor="ctr">
-                    <a:solidFill>
-                      <a:srgbClr val="FFFFFF"/>
-                    </a:solidFill>
-                  </a:tcPr>
-                </a:tc>
-              </a:tr>
-              <a:tr h="361950">
-                <a:tc>
-                  <a:txBody>
-                    <a:bodyPr/>
-                    <a:lstStyle/>
-                    <a:p>
-                      <a:pPr algn="l"/>
-                      <a:r>
-                        <a:rPr sz="1000" b="1">
-                          <a:solidFill>
-                            <a:srgbClr val="222222"/>
-                          </a:solidFill>
-                          <a:latin typeface="Arial"/>
-                          <a:ea typeface="AppleGothic"/>
-                        </a:rPr>
-                        <a:t>Sunwoda</a:t>
-                      </a:r>
-                    </a:p>
-                  </a:txBody>
-                  <a:tcPr anchor="ctr">
-                    <a:solidFill>
-                      <a:srgbClr val="F5F5F5"/>
-                    </a:solidFill>
-                  </a:tcPr>
-                </a:tc>
-                <a:tc>
-                  <a:txBody>
-                    <a:bodyPr/>
-                    <a:lstStyle/>
-                    <a:p>
-                      <a:pPr algn="ctr"/>
-                      <a:r>
-                        <a:rPr sz="1000" b="0">
-                          <a:solidFill>
-                            <a:srgbClr val="222222"/>
-                          </a:solidFill>
-                          <a:latin typeface="Arial"/>
-                          <a:ea typeface="AppleGothic"/>
-                        </a:rPr>
-                        <a:t>.939</a:t>
-                      </a:r>
-                    </a:p>
-                  </a:txBody>
-                  <a:tcPr anchor="ctr">
-                    <a:solidFill>
-                      <a:srgbClr val="F5F5F5"/>
-                    </a:solidFill>
-                  </a:tcPr>
-                </a:tc>
-                <a:tc>
-                  <a:txBody>
-                    <a:bodyPr/>
-                    <a:lstStyle/>
-                    <a:p>
-                      <a:pPr algn="ctr"/>
-                      <a:r>
-                        <a:rPr sz="1000" b="0">
-                          <a:solidFill>
-                            <a:srgbClr val="222222"/>
-                          </a:solidFill>
-                          <a:latin typeface="Arial"/>
-                          <a:ea typeface="AppleGothic"/>
-                        </a:rPr>
-                        <a:t>RBF .838</a:t>
-                      </a:r>
-                    </a:p>
-                  </a:txBody>
-                  <a:tcPr anchor="ctr">
-                    <a:solidFill>
-                      <a:srgbClr val="F5F5F5"/>
-                    </a:solidFill>
-                  </a:tcPr>
-                </a:tc>
-                <a:tc>
-                  <a:txBody>
-                    <a:bodyPr/>
-                    <a:lstStyle/>
-                    <a:p>
-                      <a:pPr algn="ctr"/>
-                      <a:r>
-                        <a:rPr sz="1000" b="0">
-                          <a:solidFill>
-                            <a:srgbClr val="222222"/>
-                          </a:solidFill>
-                          <a:latin typeface="Arial"/>
-                          <a:ea typeface="AppleGothic"/>
-                        </a:rPr>
-                        <a:t>+.102</a:t>
-                      </a:r>
-                    </a:p>
-                  </a:txBody>
-                  <a:tcPr anchor="ctr">
-                    <a:solidFill>
-                      <a:srgbClr val="F5F5F5"/>
-                    </a:solidFill>
-                  </a:tcPr>
-                </a:tc>
-                <a:tc>
-                  <a:txBody>
-                    <a:bodyPr/>
-                    <a:lstStyle/>
-                    <a:p>
-                      <a:pPr algn="ctr"/>
-                      <a:r>
-                        <a:rPr sz="1000" b="0">
-                          <a:solidFill>
-                            <a:srgbClr val="222222"/>
-                          </a:solidFill>
-                          <a:latin typeface="Arial"/>
-                          <a:ea typeface="AppleGothic"/>
-                        </a:rPr>
-                        <a:t>승</a:t>
-                      </a:r>
-                    </a:p>
-                  </a:txBody>
-                  <a:tcPr anchor="ctr">
-                    <a:solidFill>
-                      <a:srgbClr val="F5F5F5"/>
-                    </a:solidFill>
-                  </a:tcPr>
-                </a:tc>
-              </a:tr>
-              <a:tr h="361950">
-                <a:tc>
-                  <a:txBody>
-                    <a:bodyPr/>
-                    <a:lstStyle/>
-                    <a:p>
-                      <a:pPr algn="l"/>
-                      <a:r>
-                        <a:rPr sz="1000" b="1">
-                          <a:solidFill>
-                            <a:srgbClr val="222222"/>
-                          </a:solidFill>
-                          <a:latin typeface="Arial"/>
-                          <a:ea typeface="AppleGothic"/>
-                        </a:rPr>
-                        <a:t>N-CMAPSS</a:t>
-                      </a:r>
-                    </a:p>
-                  </a:txBody>
-                  <a:tcPr anchor="ctr">
-                    <a:solidFill>
-                      <a:srgbClr val="FFFFFF"/>
-                    </a:solidFill>
-                  </a:tcPr>
-                </a:tc>
-                <a:tc>
-                  <a:txBody>
-                    <a:bodyPr/>
-                    <a:lstStyle/>
-                    <a:p>
-                      <a:pPr algn="ctr"/>
-                      <a:r>
-                        <a:rPr sz="1000" b="0">
-                          <a:solidFill>
-                            <a:srgbClr val="222222"/>
-                          </a:solidFill>
-                          <a:latin typeface="Arial"/>
-                          <a:ea typeface="AppleGothic"/>
-                        </a:rPr>
-                        <a:t>.937</a:t>
-                      </a:r>
-                    </a:p>
-                  </a:txBody>
-                  <a:tcPr anchor="ctr">
-                    <a:solidFill>
-                      <a:srgbClr val="FFFFFF"/>
-                    </a:solidFill>
-                  </a:tcPr>
-                </a:tc>
-                <a:tc>
-                  <a:txBody>
-                    <a:bodyPr/>
-                    <a:lstStyle/>
-                    <a:p>
-                      <a:pPr algn="ctr"/>
-                      <a:r>
-                        <a:rPr sz="1000" b="0">
-                          <a:solidFill>
-                            <a:srgbClr val="222222"/>
-                          </a:solidFill>
-                          <a:latin typeface="Arial"/>
-                          <a:ea typeface="AppleGothic"/>
-                        </a:rPr>
-                        <a:t>Engression .932</a:t>
-                      </a:r>
-                    </a:p>
-                  </a:txBody>
-                  <a:tcPr anchor="ctr">
-                    <a:solidFill>
-                      <a:srgbClr val="FFFFFF"/>
-                    </a:solidFill>
-                  </a:tcPr>
-                </a:tc>
-                <a:tc>
-                  <a:txBody>
-                    <a:bodyPr/>
-                    <a:lstStyle/>
-                    <a:p>
-                      <a:pPr algn="ctr"/>
-                      <a:r>
-                        <a:rPr sz="1000" b="0">
-                          <a:solidFill>
-                            <a:srgbClr val="222222"/>
-                          </a:solidFill>
-                          <a:latin typeface="Arial"/>
-                          <a:ea typeface="AppleGothic"/>
-                        </a:rPr>
-                        <a:t>+.005</a:t>
-                      </a:r>
-                    </a:p>
-                  </a:txBody>
-                  <a:tcPr anchor="ctr">
-                    <a:solidFill>
-                      <a:srgbClr val="FFFFFF"/>
-                    </a:solidFill>
-                  </a:tcPr>
-                </a:tc>
-                <a:tc>
-                  <a:txBody>
-                    <a:bodyPr/>
-                    <a:lstStyle/>
-                    <a:p>
-                      <a:pPr algn="ctr"/>
-                      <a:r>
-                        <a:rPr sz="1000" b="0">
-                          <a:solidFill>
-                            <a:srgbClr val="222222"/>
-                          </a:solidFill>
-                          <a:latin typeface="Arial"/>
-                          <a:ea typeface="AppleGothic"/>
-                        </a:rPr>
-                        <a:t>승</a:t>
-                      </a:r>
-                    </a:p>
-                  </a:txBody>
-                  <a:tcPr anchor="ctr">
-                    <a:solidFill>
-                      <a:srgbClr val="FFFFFF"/>
-                    </a:solidFill>
-                  </a:tcPr>
-                </a:tc>
-              </a:tr>
-              <a:tr h="361950">
-                <a:tc>
-                  <a:txBody>
-                    <a:bodyPr/>
-                    <a:lstStyle/>
-                    <a:p>
-                      <a:pPr algn="l"/>
-                      <a:r>
-                        <a:rPr sz="1000" b="1">
-                          <a:solidFill>
-                            <a:srgbClr val="222222"/>
-                          </a:solidFill>
-                          <a:latin typeface="Arial"/>
-                          <a:ea typeface="AppleGothic"/>
-                        </a:rPr>
-                        <a:t>Virkler</a:t>
-                      </a:r>
-                    </a:p>
-                  </a:txBody>
-                  <a:tcPr anchor="ctr">
-                    <a:solidFill>
-                      <a:srgbClr val="F5F5F5"/>
-                    </a:solidFill>
-                  </a:tcPr>
-                </a:tc>
-                <a:tc>
-                  <a:txBody>
-                    <a:bodyPr/>
-                    <a:lstStyle/>
-                    <a:p>
-                      <a:pPr algn="ctr"/>
-                      <a:r>
-                        <a:rPr sz="1000" b="0">
-                          <a:solidFill>
-                            <a:srgbClr val="222222"/>
-                          </a:solidFill>
-                          <a:latin typeface="Arial"/>
-                          <a:ea typeface="AppleGothic"/>
-                        </a:rPr>
-                        <a:t>.888</a:t>
-                      </a:r>
-                    </a:p>
-                  </a:txBody>
-                  <a:tcPr anchor="ctr">
-                    <a:solidFill>
-                      <a:srgbClr val="F5F5F5"/>
-                    </a:solidFill>
-                  </a:tcPr>
-                </a:tc>
-                <a:tc>
-                  <a:txBody>
-                    <a:bodyPr/>
-                    <a:lstStyle/>
-                    <a:p>
-                      <a:pPr algn="ctr"/>
-                      <a:r>
-                        <a:rPr sz="1000" b="0">
-                          <a:solidFill>
-                            <a:srgbClr val="222222"/>
-                          </a:solidFill>
-                          <a:latin typeface="Arial"/>
-                          <a:ea typeface="AppleGothic"/>
-                        </a:rPr>
-                        <a:t>FT-Transformer .890</a:t>
-                      </a:r>
-                    </a:p>
-                  </a:txBody>
-                  <a:tcPr anchor="ctr">
-                    <a:solidFill>
-                      <a:srgbClr val="F5F5F5"/>
-                    </a:solidFill>
-                  </a:tcPr>
-                </a:tc>
-                <a:tc>
-                  <a:txBody>
-                    <a:bodyPr/>
-                    <a:lstStyle/>
-                    <a:p>
-                      <a:pPr algn="ctr"/>
-                      <a:r>
-                        <a:rPr sz="1000" b="0">
-                          <a:solidFill>
-                            <a:srgbClr val="222222"/>
-                          </a:solidFill>
-                          <a:latin typeface="Arial"/>
-                          <a:ea typeface="AppleGothic"/>
-                        </a:rPr>
-                        <a:t>−.002</a:t>
-                      </a:r>
-                    </a:p>
-                  </a:txBody>
-                  <a:tcPr anchor="ctr">
-                    <a:solidFill>
-                      <a:srgbClr val="F5F5F5"/>
-                    </a:solidFill>
-                  </a:tcPr>
-                </a:tc>
-                <a:tc>
-                  <a:txBody>
-                    <a:bodyPr/>
-                    <a:lstStyle/>
-                    <a:p>
-                      <a:pPr algn="ctr"/>
-                      <a:r>
-                        <a:rPr sz="1000" b="0">
-                          <a:solidFill>
-                            <a:srgbClr val="222222"/>
-                          </a:solidFill>
-                          <a:latin typeface="Arial"/>
-                          <a:ea typeface="AppleGothic"/>
-                        </a:rPr>
-                        <a:t>패</a:t>
-                      </a:r>
-                    </a:p>
-                  </a:txBody>
-                  <a:tcPr anchor="ctr">
-                    <a:solidFill>
-                      <a:srgbClr val="F5F5F5"/>
-                    </a:solidFill>
-                  </a:tcPr>
-                </a:tc>
-              </a:tr>
-              <a:tr h="361950">
-                <a:tc>
-                  <a:txBody>
-                    <a:bodyPr/>
-                    <a:lstStyle/>
-                    <a:p>
-                      <a:pPr algn="l"/>
-                      <a:r>
-                        <a:rPr sz="1000" b="1">
-                          <a:solidFill>
-                            <a:srgbClr val="222222"/>
-                          </a:solidFill>
-                          <a:latin typeface="Arial"/>
-                          <a:ea typeface="AppleGothic"/>
-                        </a:rPr>
-                        <a:t>RWTH</a:t>
-                      </a:r>
-                    </a:p>
-                  </a:txBody>
-                  <a:tcPr anchor="ctr">
-                    <a:solidFill>
-                      <a:srgbClr val="FFFFFF"/>
-                    </a:solidFill>
-                  </a:tcPr>
-                </a:tc>
-                <a:tc>
-                  <a:txBody>
-                    <a:bodyPr/>
-                    <a:lstStyle/>
-                    <a:p>
-                      <a:pPr algn="ctr"/>
-                      <a:r>
-                        <a:rPr sz="1000" b="0">
-                          <a:solidFill>
-                            <a:srgbClr val="222222"/>
-                          </a:solidFill>
-                          <a:latin typeface="Arial"/>
-                          <a:ea typeface="AppleGothic"/>
-                        </a:rPr>
-                        <a:t>.878</a:t>
-                      </a:r>
-                    </a:p>
-                  </a:txBody>
-                  <a:tcPr anchor="ctr">
-                    <a:solidFill>
-                      <a:srgbClr val="FFFFFF"/>
-                    </a:solidFill>
-                  </a:tcPr>
-                </a:tc>
-                <a:tc>
-                  <a:txBody>
-                    <a:bodyPr/>
-                    <a:lstStyle/>
-                    <a:p>
-                      <a:pPr algn="ctr"/>
-                      <a:r>
-                        <a:rPr sz="1000" b="0">
-                          <a:solidFill>
-                            <a:srgbClr val="222222"/>
-                          </a:solidFill>
-                          <a:latin typeface="Arial"/>
-                          <a:ea typeface="AppleGothic"/>
-                        </a:rPr>
-                        <a:t>RBF .732</a:t>
-                      </a:r>
-                    </a:p>
-                  </a:txBody>
-                  <a:tcPr anchor="ctr">
-                    <a:solidFill>
-                      <a:srgbClr val="FFFFFF"/>
-                    </a:solidFill>
-                  </a:tcPr>
-                </a:tc>
-                <a:tc>
-                  <a:txBody>
-                    <a:bodyPr/>
-                    <a:lstStyle/>
-                    <a:p>
-                      <a:pPr algn="ctr"/>
-                      <a:r>
-                        <a:rPr sz="1000" b="0">
-                          <a:solidFill>
-                            <a:srgbClr val="222222"/>
-                          </a:solidFill>
-                          <a:latin typeface="Arial"/>
-                          <a:ea typeface="AppleGothic"/>
-                        </a:rPr>
-                        <a:t>+.146</a:t>
-                      </a:r>
-                    </a:p>
-                  </a:txBody>
-                  <a:tcPr anchor="ctr">
-                    <a:solidFill>
-                      <a:srgbClr val="FFFFFF"/>
-                    </a:solidFill>
-                  </a:tcPr>
-                </a:tc>
-                <a:tc>
-                  <a:txBody>
-                    <a:bodyPr/>
-                    <a:lstStyle/>
-                    <a:p>
-                      <a:pPr algn="ctr"/>
-                      <a:r>
-                        <a:rPr sz="1000" b="0">
-                          <a:solidFill>
-                            <a:srgbClr val="222222"/>
-                          </a:solidFill>
-                          <a:latin typeface="Arial"/>
-                          <a:ea typeface="AppleGothic"/>
-                        </a:rPr>
-                        <a:t>승</a:t>
-                      </a:r>
-                    </a:p>
-                  </a:txBody>
-                  <a:tcPr anchor="ctr">
-                    <a:solidFill>
-                      <a:srgbClr val="FFFFFF"/>
-                    </a:solidFill>
-                  </a:tcPr>
-                </a:tc>
-              </a:tr>
-              <a:tr h="361950">
-                <a:tc>
-                  <a:txBody>
-                    <a:bodyPr/>
-                    <a:lstStyle/>
-                    <a:p>
-                      <a:pPr algn="l"/>
-                      <a:r>
-                        <a:rPr sz="1000" b="1">
-                          <a:solidFill>
-                            <a:srgbClr val="222222"/>
-                          </a:solidFill>
-                          <a:latin typeface="Arial"/>
-                          <a:ea typeface="AppleGothic"/>
-                        </a:rPr>
-                        <a:t>MATR-b2</a:t>
-                      </a:r>
-                    </a:p>
-                  </a:txBody>
-                  <a:tcPr anchor="ctr">
-                    <a:solidFill>
-                      <a:srgbClr val="F5F5F5"/>
-                    </a:solidFill>
-                  </a:tcPr>
-                </a:tc>
-                <a:tc>
-                  <a:txBody>
-                    <a:bodyPr/>
-                    <a:lstStyle/>
-                    <a:p>
-                      <a:pPr algn="ctr"/>
-                      <a:r>
-                        <a:rPr sz="1000" b="0">
-                          <a:solidFill>
-                            <a:srgbClr val="222222"/>
-                          </a:solidFill>
-                          <a:latin typeface="Arial"/>
-                          <a:ea typeface="AppleGothic"/>
-                        </a:rPr>
-                        <a:t>.862</a:t>
-                      </a:r>
-                    </a:p>
-                  </a:txBody>
-                  <a:tcPr anchor="ctr">
-                    <a:solidFill>
-                      <a:srgbClr val="F5F5F5"/>
-                    </a:solidFill>
-                  </a:tcPr>
-                </a:tc>
-                <a:tc>
-                  <a:txBody>
-                    <a:bodyPr/>
-                    <a:lstStyle/>
-                    <a:p>
-                      <a:pPr algn="ctr"/>
-                      <a:r>
-                        <a:rPr sz="1000" b="0">
-                          <a:solidFill>
-                            <a:srgbClr val="222222"/>
-                          </a:solidFill>
-                          <a:latin typeface="Arial"/>
-                          <a:ea typeface="AppleGothic"/>
-                        </a:rPr>
-                        <a:t>MLP .813</a:t>
-                      </a:r>
-                    </a:p>
-                  </a:txBody>
-                  <a:tcPr anchor="ctr">
-                    <a:solidFill>
-                      <a:srgbClr val="F5F5F5"/>
-                    </a:solidFill>
-                  </a:tcPr>
-                </a:tc>
-                <a:tc>
-                  <a:txBody>
-                    <a:bodyPr/>
-                    <a:lstStyle/>
-                    <a:p>
-                      <a:pPr algn="ctr"/>
-                      <a:r>
-                        <a:rPr sz="1000" b="0">
-                          <a:solidFill>
-                            <a:srgbClr val="222222"/>
-                          </a:solidFill>
-                          <a:latin typeface="Arial"/>
-                          <a:ea typeface="AppleGothic"/>
-                        </a:rPr>
-                        <a:t>+.049</a:t>
-                      </a:r>
-                    </a:p>
-                  </a:txBody>
-                  <a:tcPr anchor="ctr">
-                    <a:solidFill>
-                      <a:srgbClr val="F5F5F5"/>
-                    </a:solidFill>
-                  </a:tcPr>
-                </a:tc>
-                <a:tc>
-                  <a:txBody>
-                    <a:bodyPr/>
-                    <a:lstStyle/>
-                    <a:p>
-                      <a:pPr algn="ctr"/>
-                      <a:r>
-                        <a:rPr sz="1000" b="0">
-                          <a:solidFill>
-                            <a:srgbClr val="222222"/>
-                          </a:solidFill>
-                          <a:latin typeface="Arial"/>
-                          <a:ea typeface="AppleGothic"/>
-                        </a:rPr>
-                        <a:t>승</a:t>
-                      </a:r>
-                    </a:p>
-                  </a:txBody>
-                  <a:tcPr anchor="ctr">
-                    <a:solidFill>
-                      <a:srgbClr val="F5F5F5"/>
-                    </a:solidFill>
-                  </a:tcPr>
-                </a:tc>
-              </a:tr>
-              <a:tr h="361950">
-                <a:tc>
-                  <a:txBody>
-                    <a:bodyPr/>
-                    <a:lstStyle/>
-                    <a:p>
-                      <a:pPr algn="l"/>
-                      <a:r>
-                        <a:rPr sz="1000" b="1">
-                          <a:solidFill>
-                            <a:srgbClr val="222222"/>
-                          </a:solidFill>
-                          <a:latin typeface="Arial"/>
-                          <a:ea typeface="AppleGothic"/>
-                        </a:rPr>
-                        <a:t>MICH</a:t>
-                      </a:r>
-                    </a:p>
-                  </a:txBody>
-                  <a:tcPr anchor="ctr">
-                    <a:solidFill>
-                      <a:srgbClr val="FFFFFF"/>
-                    </a:solidFill>
-                  </a:tcPr>
-                </a:tc>
-                <a:tc>
-                  <a:txBody>
-                    <a:bodyPr/>
-                    <a:lstStyle/>
-                    <a:p>
-                      <a:pPr algn="ctr"/>
-                      <a:r>
-                        <a:rPr sz="1000" b="0">
-                          <a:solidFill>
-                            <a:srgbClr val="222222"/>
-                          </a:solidFill>
-                          <a:latin typeface="Arial"/>
-                          <a:ea typeface="AppleGothic"/>
-                        </a:rPr>
-                        <a:t>.751</a:t>
-                      </a:r>
-                    </a:p>
-                  </a:txBody>
-                  <a:tcPr anchor="ctr">
-                    <a:solidFill>
-                      <a:srgbClr val="FFFFFF"/>
-                    </a:solidFill>
-                  </a:tcPr>
-                </a:tc>
-                <a:tc>
-                  <a:txBody>
-                    <a:bodyPr/>
-                    <a:lstStyle/>
-                    <a:p>
-                      <a:pPr algn="ctr"/>
-                      <a:r>
-                        <a:rPr sz="1000" b="0">
-                          <a:solidFill>
-                            <a:srgbClr val="222222"/>
-                          </a:solidFill>
-                          <a:latin typeface="Arial"/>
-                          <a:ea typeface="AppleGothic"/>
-                        </a:rPr>
-                        <a:t>monotone −.686</a:t>
-                      </a:r>
-                    </a:p>
-                  </a:txBody>
-                  <a:tcPr anchor="ctr">
-                    <a:solidFill>
-                      <a:srgbClr val="FFFFFF"/>
-                    </a:solidFill>
-                  </a:tcPr>
-                </a:tc>
-                <a:tc>
-                  <a:txBody>
-                    <a:bodyPr/>
-                    <a:lstStyle/>
-                    <a:p>
-                      <a:pPr algn="ctr"/>
-                      <a:r>
-                        <a:rPr sz="1000" b="0">
-                          <a:solidFill>
-                            <a:srgbClr val="222222"/>
-                          </a:solidFill>
-                          <a:latin typeface="Arial"/>
-                          <a:ea typeface="AppleGothic"/>
-                        </a:rPr>
-                        <a:t>+1.437</a:t>
-                      </a:r>
-                    </a:p>
-                  </a:txBody>
-                  <a:tcPr anchor="ctr">
-                    <a:solidFill>
-                      <a:srgbClr val="FFFFFF"/>
-                    </a:solidFill>
-                  </a:tcPr>
-                </a:tc>
-                <a:tc>
-                  <a:txBody>
-                    <a:bodyPr/>
-                    <a:lstStyle/>
-                    <a:p>
-                      <a:pPr algn="ctr"/>
-                      <a:r>
-                        <a:rPr sz="1000" b="0">
-                          <a:solidFill>
-                            <a:srgbClr val="222222"/>
-                          </a:solidFill>
-                          <a:latin typeface="Arial"/>
-                          <a:ea typeface="AppleGothic"/>
-                        </a:rPr>
-                        <a:t>승</a:t>
-                      </a:r>
-                    </a:p>
-                  </a:txBody>
-                  <a:tcPr anchor="ctr">
-                    <a:solidFill>
-                      <a:srgbClr val="FFFFFF"/>
-                    </a:solidFill>
-                  </a:tcPr>
-                </a:tc>
-              </a:tr>
-              <a:tr h="361950">
-                <a:tc>
-                  <a:txBody>
-                    <a:bodyPr/>
-                    <a:lstStyle/>
-                    <a:p>
-                      <a:pPr algn="l"/>
-                      <a:r>
-                        <a:rPr sz="1000" b="1">
-                          <a:solidFill>
-                            <a:srgbClr val="222222"/>
-                          </a:solidFill>
-                          <a:latin typeface="Arial"/>
-                          <a:ea typeface="AppleGothic"/>
-                        </a:rPr>
-                        <a:t>NASA</a:t>
-                      </a:r>
-                    </a:p>
-                  </a:txBody>
-                  <a:tcPr anchor="ctr">
-                    <a:solidFill>
-                      <a:srgbClr val="F5F5F5"/>
-                    </a:solidFill>
-                  </a:tcPr>
-                </a:tc>
-                <a:tc>
-                  <a:txBody>
-                    <a:bodyPr/>
-                    <a:lstStyle/>
-                    <a:p>
-                      <a:pPr algn="ctr"/>
-                      <a:r>
-                        <a:rPr sz="1000" b="0">
-                          <a:solidFill>
-                            <a:srgbClr val="222222"/>
-                          </a:solidFill>
-                          <a:latin typeface="Arial"/>
-                          <a:ea typeface="AppleGothic"/>
-                        </a:rPr>
-                        <a:t>.584</a:t>
-                      </a:r>
-                    </a:p>
-                  </a:txBody>
-                  <a:tcPr anchor="ctr">
-                    <a:solidFill>
-                      <a:srgbClr val="F5F5F5"/>
-                    </a:solidFill>
-                  </a:tcPr>
-                </a:tc>
-                <a:tc>
-                  <a:txBody>
-                    <a:bodyPr/>
-                    <a:lstStyle/>
-                    <a:p>
-                      <a:pPr algn="ctr"/>
-                      <a:r>
-                        <a:rPr sz="1000" b="0">
-                          <a:solidFill>
-                            <a:srgbClr val="222222"/>
-                          </a:solidFill>
-                          <a:latin typeface="Arial"/>
-                          <a:ea typeface="AppleGothic"/>
-                        </a:rPr>
-                        <a:t>Engression .583</a:t>
-                      </a:r>
-                    </a:p>
-                  </a:txBody>
-                  <a:tcPr anchor="ctr">
-                    <a:solidFill>
-                      <a:srgbClr val="F5F5F5"/>
-                    </a:solidFill>
-                  </a:tcPr>
-                </a:tc>
-                <a:tc>
-                  <a:txBody>
-                    <a:bodyPr/>
-                    <a:lstStyle/>
-                    <a:p>
-                      <a:pPr algn="ctr"/>
-                      <a:r>
-                        <a:rPr sz="1000" b="0">
-                          <a:solidFill>
-                            <a:srgbClr val="222222"/>
-                          </a:solidFill>
-                          <a:latin typeface="Arial"/>
-                          <a:ea typeface="AppleGothic"/>
-                        </a:rPr>
-                        <a:t>~0</a:t>
-                      </a:r>
-                    </a:p>
-                  </a:txBody>
-                  <a:tcPr anchor="ctr">
-                    <a:solidFill>
-                      <a:srgbClr val="F5F5F5"/>
-                    </a:solidFill>
-                  </a:tcPr>
-                </a:tc>
-                <a:tc>
-                  <a:txBody>
-                    <a:bodyPr/>
-                    <a:lstStyle/>
-                    <a:p>
-                      <a:pPr algn="ctr"/>
-                      <a:r>
-                        <a:rPr sz="1000" b="0">
-                          <a:solidFill>
-                            <a:srgbClr val="222222"/>
-                          </a:solidFill>
-                          <a:latin typeface="Arial"/>
-                          <a:ea typeface="AppleGothic"/>
-                        </a:rPr>
-                        <a:t>승</a:t>
-                      </a:r>
-                    </a:p>
-                  </a:txBody>
-                  <a:tcPr anchor="ctr">
-                    <a:solidFill>
-                      <a:srgbClr val="F5F5F5"/>
-                    </a:solidFill>
-                  </a:tcPr>
-                </a:tc>
-              </a:tr>
-              <a:tr h="361950">
-                <a:tc>
-                  <a:txBody>
-                    <a:bodyPr/>
-                    <a:lstStyle/>
-                    <a:p>
-                      <a:pPr algn="l"/>
-                      <a:r>
-                        <a:rPr sz="1000" b="1">
-                          <a:solidFill>
-                            <a:srgbClr val="222222"/>
-                          </a:solidFill>
-                          <a:latin typeface="Arial"/>
-                          <a:ea typeface="AppleGothic"/>
-                        </a:rPr>
-                        <a:t>MATR19</a:t>
-                      </a:r>
-                    </a:p>
-                  </a:txBody>
-                  <a:tcPr anchor="ctr">
-                    <a:solidFill>
-                      <a:srgbClr val="FFFFFF"/>
-                    </a:solidFill>
-                  </a:tcPr>
-                </a:tc>
-                <a:tc>
-                  <a:txBody>
-                    <a:bodyPr/>
-                    <a:lstStyle/>
-                    <a:p>
-                      <a:pPr algn="ctr"/>
-                      <a:r>
-                        <a:rPr sz="1000" b="0">
-                          <a:solidFill>
-                            <a:srgbClr val="222222"/>
-                          </a:solidFill>
-                          <a:latin typeface="Arial"/>
-                          <a:ea typeface="AppleGothic"/>
-                        </a:rPr>
-                        <a:t>.466</a:t>
-                      </a:r>
-                    </a:p>
-                  </a:txBody>
-                  <a:tcPr anchor="ctr">
-                    <a:solidFill>
-                      <a:srgbClr val="FFFFFF"/>
-                    </a:solidFill>
-                  </a:tcPr>
-                </a:tc>
-                <a:tc>
-                  <a:txBody>
-                    <a:bodyPr/>
-                    <a:lstStyle/>
-                    <a:p>
-                      <a:pPr algn="ctr"/>
-                      <a:r>
-                        <a:rPr sz="1000" b="0">
-                          <a:solidFill>
-                            <a:srgbClr val="222222"/>
-                          </a:solidFill>
-                          <a:latin typeface="Arial"/>
-                          <a:ea typeface="AppleGothic"/>
-                        </a:rPr>
-                        <a:t>FT-Transformer .342</a:t>
-                      </a:r>
-                    </a:p>
-                  </a:txBody>
-                  <a:tcPr anchor="ctr">
-                    <a:solidFill>
-                      <a:srgbClr val="FFFFFF"/>
-                    </a:solidFill>
-                  </a:tcPr>
-                </a:tc>
-                <a:tc>
-                  <a:txBody>
-                    <a:bodyPr/>
-                    <a:lstStyle/>
-                    <a:p>
-                      <a:pPr algn="ctr"/>
-                      <a:r>
-                        <a:rPr sz="1000" b="0">
-                          <a:solidFill>
-                            <a:srgbClr val="222222"/>
-                          </a:solidFill>
-                          <a:latin typeface="Arial"/>
-                          <a:ea typeface="AppleGothic"/>
-                        </a:rPr>
-                        <a:t>+.123</a:t>
-                      </a:r>
-                    </a:p>
-                  </a:txBody>
-                  <a:tcPr anchor="ctr">
-                    <a:solidFill>
-                      <a:srgbClr val="FFFFFF"/>
-                    </a:solidFill>
-                  </a:tcPr>
-                </a:tc>
-                <a:tc>
-                  <a:txBody>
-                    <a:bodyPr/>
-                    <a:lstStyle/>
-                    <a:p>
-                      <a:pPr algn="ctr"/>
-                      <a:r>
-                        <a:rPr sz="1000" b="0">
-                          <a:solidFill>
-                            <a:srgbClr val="222222"/>
-                          </a:solidFill>
-                          <a:latin typeface="Arial"/>
-                          <a:ea typeface="AppleGothic"/>
-                        </a:rPr>
-                        <a:t>승</a:t>
-                      </a:r>
-                    </a:p>
-                  </a:txBody>
-                  <a:tcPr anchor="ctr">
-                    <a:solidFill>
-                      <a:srgbClr val="FFFFFF"/>
-                    </a:solidFill>
-                  </a:tcPr>
-                </a:tc>
-              </a:tr>
-            </a:tbl>
-          </a:graphicData>
-        </a:graphic>
-      </p:graphicFrame>
-      <p:sp>
-        <p:nvSpPr>
-          <p:cNvPr id="7" name="Rectangle 6"/>
-          <p:cNvSpPr/>
-          <p:nvPr/>
-        </p:nvSpPr>
-        <p:spPr>
-          <a:xfrm>
-            <a:off x="904875" y="4810125"/>
-            <a:ext cx="4762500" cy="809625"/>
-          </a:xfrm>
-          <a:prstGeom prst="rect">
-            <a:avLst/>
-          </a:prstGeom>
-          <a:solidFill>
-            <a:srgbClr val="E8F1F8"/>
-          </a:solidFill>
-          <a:ln w="15875">
-            <a:solidFill>
-              <a:srgbClr val="0072B2"/>
-            </a:solidFill>
-          </a:ln>
-        </p:spPr>
-        <p:style>
-          <a:lnRef idx="1">
-            <a:schemeClr val="accent1"/>
-          </a:lnRef>
-          <a:fillRef idx="3">
-            <a:schemeClr val="accent1"/>
-          </a:fillRef>
-          <a:effectRef idx="2">
-            <a:schemeClr val="accent1"/>
-          </a:effectRef>
-          <a:fontRef idx="minor">
-            <a:schemeClr val="lt1"/>
-          </a:fontRef>
-        </p:style>
-        <p:txBody>
-          <a:bodyPr rtlCol="0" anchor="ctr"/>
-          <a:lstStyle/>
-          <a:p>
-            <a:pPr algn="ctr"/>
-          </a:p>
-        </p:txBody>
-      </p:sp>
-      <p:sp>
-        <p:nvSpPr>
-          <p:cNvPr id="8" name="TextBox 7"/>
-          <p:cNvSpPr txBox="1"/>
-          <p:nvPr/>
-        </p:nvSpPr>
-        <p:spPr>
-          <a:xfrm>
-            <a:off x="1047750" y="4933950"/>
-            <a:ext cx="4476750" cy="514350"/>
-          </a:xfrm>
-          <a:prstGeom prst="rect">
-            <a:avLst/>
-          </a:prstGeom>
-          <a:noFill/>
-        </p:spPr>
-        <p:txBody>
-          <a:bodyPr wrap="square">
-            <a:spAutoFit/>
-          </a:bodyPr>
-          <a:lstStyle/>
-          <a:p>
-            <a:pPr algn="ctr"/>
-            <a:r>
-              <a:rPr sz="1500" b="1">
-                <a:solidFill>
-                  <a:srgbClr val="0072B2"/>
-                </a:solidFill>
-                <a:latin typeface="Arial"/>
-                <a:ea typeface="AppleGothic"/>
-              </a:rPr>
-              <a:t>8 / 9 우세 · two-sided exact p=.0391</a:t>
-            </a:r>
-          </a:p>
-        </p:txBody>
-      </p:sp>
-      <p:sp>
-        <p:nvSpPr>
-          <p:cNvPr id="9" name="Rectangle 8"/>
-          <p:cNvSpPr/>
-          <p:nvPr/>
-        </p:nvSpPr>
-        <p:spPr>
-          <a:xfrm>
-            <a:off x="6477000" y="4810125"/>
-            <a:ext cx="4762500" cy="809625"/>
-          </a:xfrm>
-          <a:prstGeom prst="rect">
-            <a:avLst/>
-          </a:prstGeom>
-          <a:solidFill>
-            <a:srgbClr val="FDF4E3"/>
-          </a:solidFill>
-          <a:ln w="15875">
-            <a:solidFill>
-              <a:srgbClr val="E69F00"/>
-            </a:solidFill>
-          </a:ln>
-        </p:spPr>
-        <p:style>
-          <a:lnRef idx="1">
-            <a:schemeClr val="accent1"/>
-          </a:lnRef>
-          <a:fillRef idx="3">
-            <a:schemeClr val="accent1"/>
-          </a:fillRef>
-          <a:effectRef idx="2">
-            <a:schemeClr val="accent1"/>
-          </a:effectRef>
-          <a:fontRef idx="minor">
-            <a:schemeClr val="lt1"/>
-          </a:fontRef>
-        </p:style>
-        <p:txBody>
-          <a:bodyPr rtlCol="0" anchor="ctr"/>
-          <a:lstStyle/>
-          <a:p>
-            <a:pPr algn="ctr"/>
-          </a:p>
-        </p:txBody>
-      </p:sp>
-      <p:sp>
-        <p:nvSpPr>
-          <p:cNvPr id="10" name="TextBox 9"/>
-          <p:cNvSpPr txBox="1"/>
-          <p:nvPr/>
-        </p:nvSpPr>
-        <p:spPr>
-          <a:xfrm>
-            <a:off x="6619875" y="4933950"/>
-            <a:ext cx="4476750" cy="514350"/>
-          </a:xfrm>
-          <a:prstGeom prst="rect">
-            <a:avLst/>
-          </a:prstGeom>
-          <a:noFill/>
-        </p:spPr>
-        <p:txBody>
-          <a:bodyPr wrap="square">
-            <a:spAutoFit/>
-          </a:bodyPr>
-          <a:lstStyle/>
-          <a:p>
-            <a:pPr algn="ctr"/>
-            <a:r>
-              <a:rPr sz="1300" b="1">
-                <a:solidFill>
-                  <a:srgbClr val="E69F00"/>
-                </a:solidFill>
-                <a:latin typeface="Arial"/>
-                <a:ea typeface="AppleGothic"/>
-              </a:rPr>
-              <a:t>Virkler에서는 FT-Transformer가 +.002 우세</a:t>
-            </a:r>
-          </a:p>
-        </p:txBody>
-      </p:sp>
-      <p:sp>
-        <p:nvSpPr>
-          <p:cNvPr id="11" name="TextBox 10"/>
-          <p:cNvSpPr txBox="1"/>
-          <p:nvPr/>
-        </p:nvSpPr>
-        <p:spPr>
-          <a:xfrm>
-            <a:off x="571500" y="5857875"/>
-            <a:ext cx="11049000" cy="323850"/>
-          </a:xfrm>
-          <a:prstGeom prst="rect">
-            <a:avLst/>
-          </a:prstGeom>
-          <a:noFill/>
-        </p:spPr>
-        <p:txBody>
-          <a:bodyPr wrap="square">
-            <a:spAutoFit/>
-          </a:bodyPr>
-          <a:lstStyle/>
-          <a:p>
-            <a:pPr algn="ctr"/>
-            <a:r>
-              <a:rPr sz="1200" b="1">
-                <a:solidFill>
-                  <a:srgbClr val="666666"/>
-                </a:solidFill>
-                <a:latin typeface="Arial"/>
-                <a:ea typeface="AppleGothic"/>
-              </a:rPr>
-              <a:t>이 검정은 prior 구조의 내부 효과가 아니라, 동일한 탐색 예산 아래 외부 모델과의 경쟁력을 묻는다.</a:t>
-            </a:r>
-          </a:p>
-        </p:txBody>
-      </p:sp>
-      <p:sp>
-        <p:nvSpPr>
-          <p:cNvPr id="12" name="TextBox 11"/>
-          <p:cNvSpPr txBox="1"/>
-          <p:nvPr/>
-        </p:nvSpPr>
-        <p:spPr>
-          <a:xfrm>
-            <a:off x="10858500" y="6419850"/>
-            <a:ext cx="838200" cy="171450"/>
-          </a:xfrm>
-          <a:prstGeom prst="rect">
-            <a:avLst/>
-          </a:prstGeom>
-          <a:noFill/>
-        </p:spPr>
-        <p:txBody>
-          <a:bodyPr wrap="square">
-            <a:spAutoFit/>
-          </a:bodyPr>
-          <a:lstStyle/>
-          <a:p>
-            <a:pPr algn="r"/>
-            <a:r>
-              <a:rPr sz="900" b="1">
-                <a:solidFill>
-                  <a:srgbClr val="666666"/>
-                </a:solidFill>
-                <a:latin typeface="Arial"/>
-                <a:ea typeface="AppleGothic"/>
-              </a:rPr>
-              <a:t>15/18</a:t>
             </a:r>
           </a:p>
         </p:txBody>
@@ -15632,1395 +13018,6 @@
                 <a:ea typeface="AppleGothic"/>
               </a:rPr>
               <a:t>16/18</a:t>
-            </a:r>
-          </a:p>
-        </p:txBody>
-      </p:sp>
-    </p:spTree>
-  </p:cSld>
-  <p:clrMapOvr>
-    <a:masterClrMapping/>
-  </p:clrMapOvr>
-</p:sld>
-</file>
-
-<file path=ppt/slides/slide17.xml><?xml version="1.0" encoding="utf-8"?>
-<p:sld xmlns:a="http://schemas.openxmlformats.org/drawingml/2006/main" xmlns:p="http://schemas.openxmlformats.org/presentationml/2006/main" xmlns:r="http://schemas.openxmlformats.org/officeDocument/2006/relationships">
-  <p:cSld>
-    <p:spTree>
-      <p:nvGrpSpPr>
-        <p:cNvPr id="1" name=""/>
-        <p:cNvGrpSpPr/>
-        <p:nvPr/>
-      </p:nvGrpSpPr>
-      <p:grpSpPr/>
-      <p:sp>
-        <p:nvSpPr>
-          <p:cNvPr id="2" name="Rectangle 1"/>
-          <p:cNvSpPr/>
-          <p:nvPr/>
-        </p:nvSpPr>
-        <p:spPr>
-          <a:xfrm>
-            <a:off x="0" y="0"/>
-            <a:ext cx="12192000" cy="6858000"/>
-          </a:xfrm>
-          <a:prstGeom prst="rect">
-            <a:avLst/>
-          </a:prstGeom>
-          <a:solidFill>
-            <a:srgbClr val="FFFFFF"/>
-          </a:solidFill>
-          <a:ln>
-            <a:noFill/>
-          </a:ln>
-        </p:spPr>
-        <p:style>
-          <a:lnRef idx="1">
-            <a:schemeClr val="accent1"/>
-          </a:lnRef>
-          <a:fillRef idx="3">
-            <a:schemeClr val="accent1"/>
-          </a:fillRef>
-          <a:effectRef idx="2">
-            <a:schemeClr val="accent1"/>
-          </a:effectRef>
-          <a:fontRef idx="minor">
-            <a:schemeClr val="lt1"/>
-          </a:fontRef>
-        </p:style>
-        <p:txBody>
-          <a:bodyPr rtlCol="0" anchor="ctr"/>
-          <a:lstStyle/>
-          <a:p>
-            <a:pPr algn="ctr"/>
-          </a:p>
-        </p:txBody>
-      </p:sp>
-      <p:sp>
-        <p:nvSpPr>
-          <p:cNvPr id="3" name="Rectangle 2"/>
-          <p:cNvSpPr/>
-          <p:nvPr/>
-        </p:nvSpPr>
-        <p:spPr>
-          <a:xfrm>
-            <a:off x="0" y="0"/>
-            <a:ext cx="12192000" cy="19050"/>
-          </a:xfrm>
-          <a:prstGeom prst="rect">
-            <a:avLst/>
-          </a:prstGeom>
-          <a:solidFill>
-            <a:srgbClr val="222222"/>
-          </a:solidFill>
-          <a:ln>
-            <a:noFill/>
-          </a:ln>
-        </p:spPr>
-        <p:style>
-          <a:lnRef idx="1">
-            <a:schemeClr val="accent1"/>
-          </a:lnRef>
-          <a:fillRef idx="3">
-            <a:schemeClr val="accent1"/>
-          </a:fillRef>
-          <a:effectRef idx="2">
-            <a:schemeClr val="accent1"/>
-          </a:effectRef>
-          <a:fontRef idx="minor">
-            <a:schemeClr val="lt1"/>
-          </a:fontRef>
-        </p:style>
-        <p:txBody>
-          <a:bodyPr rtlCol="0" anchor="ctr"/>
-          <a:lstStyle/>
-          <a:p>
-            <a:pPr algn="ctr"/>
-          </a:p>
-        </p:txBody>
-      </p:sp>
-      <p:sp>
-        <p:nvSpPr>
-          <p:cNvPr id="4" name="TextBox 3"/>
-          <p:cNvSpPr txBox="1"/>
-          <p:nvPr/>
-        </p:nvSpPr>
-        <p:spPr>
-          <a:xfrm>
-            <a:off x="457200" y="209550"/>
-            <a:ext cx="11239500" cy="304800"/>
-          </a:xfrm>
-          <a:prstGeom prst="rect">
-            <a:avLst/>
-          </a:prstGeom>
-          <a:noFill/>
-        </p:spPr>
-        <p:txBody>
-          <a:bodyPr wrap="square">
-            <a:spAutoFit/>
-          </a:bodyPr>
-          <a:lstStyle/>
-          <a:p>
-            <a:pPr algn="l"/>
-            <a:r>
-              <a:rPr sz="2200" b="1">
-                <a:solidFill>
-                  <a:srgbClr val="222222"/>
-                </a:solidFill>
-                <a:latin typeface="Arial"/>
-                <a:ea typeface="AppleGothic"/>
-              </a:rPr>
-              <a:t>검정 4 — ‘외삽이 덜 무너진다’의 근거와 한계</a:t>
-            </a:r>
-          </a:p>
-        </p:txBody>
-      </p:sp>
-      <p:sp>
-        <p:nvSpPr>
-          <p:cNvPr id="5" name="TextBox 4"/>
-          <p:cNvSpPr txBox="1"/>
-          <p:nvPr/>
-        </p:nvSpPr>
-        <p:spPr>
-          <a:xfrm>
-            <a:off x="457200" y="514350"/>
-            <a:ext cx="11239500" cy="190500"/>
-          </a:xfrm>
-          <a:prstGeom prst="rect">
-            <a:avLst/>
-          </a:prstGeom>
-          <a:noFill/>
-        </p:spPr>
-        <p:txBody>
-          <a:bodyPr wrap="square">
-            <a:spAutoFit/>
-          </a:bodyPr>
-          <a:lstStyle/>
-          <a:p>
-            <a:pPr algn="l"/>
-            <a:r>
-              <a:rPr sz="1200" b="0">
-                <a:solidFill>
-                  <a:srgbClr val="666666"/>
-                </a:solidFill>
-                <a:latin typeface="Arial"/>
-                <a:ea typeface="AppleGothic"/>
-              </a:rPr>
-              <a:t>성능 평균뿐 아니라 setting 간 편차·최악 점수·음의 R² 발생을 함께 본다.</a:t>
-            </a:r>
-          </a:p>
-        </p:txBody>
-      </p:sp>
-      <p:graphicFrame>
-        <p:nvGraphicFramePr>
-          <p:cNvPr id="6" name="Table 5"/>
-          <p:cNvGraphicFramePr>
-            <a:graphicFrameLocks noGrp="1"/>
-          </p:cNvGraphicFramePr>
-          <p:nvPr/>
-        </p:nvGraphicFramePr>
-        <p:xfrm>
-          <a:off x="457200" y="914400"/>
-          <a:ext cx="6953250" cy="3143250"/>
-        </p:xfrm>
-        <a:graphic>
-          <a:graphicData uri="http://schemas.openxmlformats.org/drawingml/2006/table">
-            <a:tbl>
-              <a:tblPr firstRow="1" bandRow="1">
-                <a:tableStyleId>{5C22544A-7EE6-4342-B048-85BDC9FD1C3A}</a:tableStyleId>
-              </a:tblPr>
-              <a:tblGrid>
-                <a:gridCol w="1390650"/>
-                <a:gridCol w="1390650"/>
-                <a:gridCol w="1390650"/>
-                <a:gridCol w="1390650"/>
-                <a:gridCol w="1390650"/>
-              </a:tblGrid>
-              <a:tr h="523875">
-                <a:tc>
-                  <a:txBody>
-                    <a:bodyPr/>
-                    <a:lstStyle/>
-                    <a:p>
-                      <a:pPr algn="ctr"/>
-                      <a:r>
-                        <a:rPr sz="1100" b="1">
-                          <a:solidFill>
-                            <a:srgbClr val="FFFFFF"/>
-                          </a:solidFill>
-                          <a:latin typeface="Arial"/>
-                          <a:ea typeface="AppleGothic"/>
-                        </a:rPr>
-                        <a:t>모델</a:t>
-                      </a:r>
-                    </a:p>
-                  </a:txBody>
-                  <a:tcPr anchor="ctr">
-                    <a:solidFill>
-                      <a:srgbClr val="222222"/>
-                    </a:solidFill>
-                  </a:tcPr>
-                </a:tc>
-                <a:tc>
-                  <a:txBody>
-                    <a:bodyPr/>
-                    <a:lstStyle/>
-                    <a:p>
-                      <a:pPr algn="ctr"/>
-                      <a:r>
-                        <a:rPr sz="1100" b="1">
-                          <a:solidFill>
-                            <a:srgbClr val="FFFFFF"/>
-                          </a:solidFill>
-                          <a:latin typeface="Arial"/>
-                          <a:ea typeface="AppleGothic"/>
-                        </a:rPr>
-                        <a:t>macro R²</a:t>
-                      </a:r>
-                    </a:p>
-                  </a:txBody>
-                  <a:tcPr anchor="ctr">
-                    <a:solidFill>
-                      <a:srgbClr val="222222"/>
-                    </a:solidFill>
-                  </a:tcPr>
-                </a:tc>
-                <a:tc>
-                  <a:txBody>
-                    <a:bodyPr/>
-                    <a:lstStyle/>
-                    <a:p>
-                      <a:pPr algn="ctr"/>
-                      <a:r>
-                        <a:rPr sz="1100" b="1">
-                          <a:solidFill>
-                            <a:srgbClr val="FFFFFF"/>
-                          </a:solidFill>
-                          <a:latin typeface="Arial"/>
-                          <a:ea typeface="AppleGothic"/>
-                        </a:rPr>
-                        <a:t>setting SD</a:t>
-                      </a:r>
-                    </a:p>
-                  </a:txBody>
-                  <a:tcPr anchor="ctr">
-                    <a:solidFill>
-                      <a:srgbClr val="222222"/>
-                    </a:solidFill>
-                  </a:tcPr>
-                </a:tc>
-                <a:tc>
-                  <a:txBody>
-                    <a:bodyPr/>
-                    <a:lstStyle/>
-                    <a:p>
-                      <a:pPr algn="ctr"/>
-                      <a:r>
-                        <a:rPr sz="1100" b="1">
-                          <a:solidFill>
-                            <a:srgbClr val="FFFFFF"/>
-                          </a:solidFill>
-                          <a:latin typeface="Arial"/>
-                          <a:ea typeface="AppleGothic"/>
-                        </a:rPr>
-                        <a:t>최악 R²</a:t>
-                      </a:r>
-                    </a:p>
-                  </a:txBody>
-                  <a:tcPr anchor="ctr">
-                    <a:solidFill>
-                      <a:srgbClr val="222222"/>
-                    </a:solidFill>
-                  </a:tcPr>
-                </a:tc>
-                <a:tc>
-                  <a:txBody>
-                    <a:bodyPr/>
-                    <a:lstStyle/>
-                    <a:p>
-                      <a:pPr algn="ctr"/>
-                      <a:r>
-                        <a:rPr sz="1100" b="1">
-                          <a:solidFill>
-                            <a:srgbClr val="FFFFFF"/>
-                          </a:solidFill>
-                          <a:latin typeface="Arial"/>
-                          <a:ea typeface="AppleGothic"/>
-                        </a:rPr>
-                        <a:t>R²&gt;0</a:t>
-                      </a:r>
-                    </a:p>
-                  </a:txBody>
-                  <a:tcPr anchor="ctr">
-                    <a:solidFill>
-                      <a:srgbClr val="222222"/>
-                    </a:solidFill>
-                  </a:tcPr>
-                </a:tc>
-              </a:tr>
-              <a:tr h="523875">
-                <a:tc>
-                  <a:txBody>
-                    <a:bodyPr/>
-                    <a:lstStyle/>
-                    <a:p>
-                      <a:pPr algn="l"/>
-                      <a:r>
-                        <a:rPr sz="1100" b="1">
-                          <a:solidFill>
-                            <a:srgbClr val="222222"/>
-                          </a:solidFill>
-                          <a:latin typeface="Arial"/>
-                          <a:ea typeface="AppleGothic"/>
-                        </a:rPr>
-                        <a:t>PP-X</a:t>
-                      </a:r>
-                    </a:p>
-                  </a:txBody>
-                  <a:tcPr anchor="ctr">
-                    <a:solidFill>
-                      <a:srgbClr val="FFFFFF"/>
-                    </a:solidFill>
-                  </a:tcPr>
-                </a:tc>
-                <a:tc>
-                  <a:txBody>
-                    <a:bodyPr/>
-                    <a:lstStyle/>
-                    <a:p>
-                      <a:pPr algn="ctr"/>
-                      <a:r>
-                        <a:rPr sz="1100" b="0">
-                          <a:solidFill>
-                            <a:srgbClr val="222222"/>
-                          </a:solidFill>
-                          <a:latin typeface="Arial"/>
-                          <a:ea typeface="AppleGothic"/>
-                        </a:rPr>
-                        <a:t>.807</a:t>
-                      </a:r>
-                    </a:p>
-                  </a:txBody>
-                  <a:tcPr anchor="ctr">
-                    <a:solidFill>
-                      <a:srgbClr val="FFFFFF"/>
-                    </a:solidFill>
-                  </a:tcPr>
-                </a:tc>
-                <a:tc>
-                  <a:txBody>
-                    <a:bodyPr/>
-                    <a:lstStyle/>
-                    <a:p>
-                      <a:pPr algn="ctr"/>
-                      <a:r>
-                        <a:rPr sz="1100" b="0">
-                          <a:solidFill>
-                            <a:srgbClr val="222222"/>
-                          </a:solidFill>
-                          <a:latin typeface="Arial"/>
-                          <a:ea typeface="AppleGothic"/>
-                        </a:rPr>
-                        <a:t>.174</a:t>
-                      </a:r>
-                    </a:p>
-                  </a:txBody>
-                  <a:tcPr anchor="ctr">
-                    <a:solidFill>
-                      <a:srgbClr val="FFFFFF"/>
-                    </a:solidFill>
-                  </a:tcPr>
-                </a:tc>
-                <a:tc>
-                  <a:txBody>
-                    <a:bodyPr/>
-                    <a:lstStyle/>
-                    <a:p>
-                      <a:pPr algn="ctr"/>
-                      <a:r>
-                        <a:rPr sz="1100" b="0">
-                          <a:solidFill>
-                            <a:srgbClr val="222222"/>
-                          </a:solidFill>
-                          <a:latin typeface="Arial"/>
-                          <a:ea typeface="AppleGothic"/>
-                        </a:rPr>
-                        <a:t>.466</a:t>
-                      </a:r>
-                    </a:p>
-                  </a:txBody>
-                  <a:tcPr anchor="ctr">
-                    <a:solidFill>
-                      <a:srgbClr val="FFFFFF"/>
-                    </a:solidFill>
-                  </a:tcPr>
-                </a:tc>
-                <a:tc>
-                  <a:txBody>
-                    <a:bodyPr/>
-                    <a:lstStyle/>
-                    <a:p>
-                      <a:pPr algn="ctr"/>
-                      <a:r>
-                        <a:rPr sz="1100" b="0">
-                          <a:solidFill>
-                            <a:srgbClr val="222222"/>
-                          </a:solidFill>
-                          <a:latin typeface="Arial"/>
-                          <a:ea typeface="AppleGothic"/>
-                        </a:rPr>
-                        <a:t>9/9</a:t>
-                      </a:r>
-                    </a:p>
-                  </a:txBody>
-                  <a:tcPr anchor="ctr">
-                    <a:solidFill>
-                      <a:srgbClr val="FFFFFF"/>
-                    </a:solidFill>
-                  </a:tcPr>
-                </a:tc>
-              </a:tr>
-              <a:tr h="523875">
-                <a:tc>
-                  <a:txBody>
-                    <a:bodyPr/>
-                    <a:lstStyle/>
-                    <a:p>
-                      <a:pPr algn="l"/>
-                      <a:r>
-                        <a:rPr sz="1100" b="1">
-                          <a:solidFill>
-                            <a:srgbClr val="222222"/>
-                          </a:solidFill>
-                          <a:latin typeface="Arial"/>
-                          <a:ea typeface="AppleGothic"/>
-                        </a:rPr>
-                        <a:t>Engression</a:t>
-                      </a:r>
-                    </a:p>
-                  </a:txBody>
-                  <a:tcPr anchor="ctr">
-                    <a:solidFill>
-                      <a:srgbClr val="F5F5F5"/>
-                    </a:solidFill>
-                  </a:tcPr>
-                </a:tc>
-                <a:tc>
-                  <a:txBody>
-                    <a:bodyPr/>
-                    <a:lstStyle/>
-                    <a:p>
-                      <a:pPr algn="ctr"/>
-                      <a:r>
-                        <a:rPr sz="1100" b="0">
-                          <a:solidFill>
-                            <a:srgbClr val="222222"/>
-                          </a:solidFill>
-                          <a:latin typeface="Arial"/>
-                          <a:ea typeface="AppleGothic"/>
-                        </a:rPr>
-                        <a:t>.257</a:t>
-                      </a:r>
-                    </a:p>
-                  </a:txBody>
-                  <a:tcPr anchor="ctr">
-                    <a:solidFill>
-                      <a:srgbClr val="F5F5F5"/>
-                    </a:solidFill>
-                  </a:tcPr>
-                </a:tc>
-                <a:tc>
-                  <a:txBody>
-                    <a:bodyPr/>
-                    <a:lstStyle/>
-                    <a:p>
-                      <a:pPr algn="ctr"/>
-                      <a:r>
-                        <a:rPr sz="1100" b="0">
-                          <a:solidFill>
-                            <a:srgbClr val="222222"/>
-                          </a:solidFill>
-                          <a:latin typeface="Arial"/>
-                          <a:ea typeface="AppleGothic"/>
-                        </a:rPr>
-                        <a:t>.949</a:t>
-                      </a:r>
-                    </a:p>
-                  </a:txBody>
-                  <a:tcPr anchor="ctr">
-                    <a:solidFill>
-                      <a:srgbClr val="F5F5F5"/>
-                    </a:solidFill>
-                  </a:tcPr>
-                </a:tc>
-                <a:tc>
-                  <a:txBody>
-                    <a:bodyPr/>
-                    <a:lstStyle/>
-                    <a:p>
-                      <a:pPr algn="ctr"/>
-                      <a:r>
-                        <a:rPr sz="1100" b="0">
-                          <a:solidFill>
-                            <a:srgbClr val="222222"/>
-                          </a:solidFill>
-                          <a:latin typeface="Arial"/>
-                          <a:ea typeface="AppleGothic"/>
-                        </a:rPr>
-                        <a:t>−1.580</a:t>
-                      </a:r>
-                    </a:p>
-                  </a:txBody>
-                  <a:tcPr anchor="ctr">
-                    <a:solidFill>
-                      <a:srgbClr val="F5F5F5"/>
-                    </a:solidFill>
-                  </a:tcPr>
-                </a:tc>
-                <a:tc>
-                  <a:txBody>
-                    <a:bodyPr/>
-                    <a:lstStyle/>
-                    <a:p>
-                      <a:pPr algn="ctr"/>
-                      <a:r>
-                        <a:rPr sz="1100" b="0">
-                          <a:solidFill>
-                            <a:srgbClr val="222222"/>
-                          </a:solidFill>
-                          <a:latin typeface="Arial"/>
-                          <a:ea typeface="AppleGothic"/>
-                        </a:rPr>
-                        <a:t>7/9</a:t>
-                      </a:r>
-                    </a:p>
-                  </a:txBody>
-                  <a:tcPr anchor="ctr">
-                    <a:solidFill>
-                      <a:srgbClr val="F5F5F5"/>
-                    </a:solidFill>
-                  </a:tcPr>
-                </a:tc>
-              </a:tr>
-              <a:tr h="523875">
-                <a:tc>
-                  <a:txBody>
-                    <a:bodyPr/>
-                    <a:lstStyle/>
-                    <a:p>
-                      <a:pPr algn="l"/>
-                      <a:r>
-                        <a:rPr sz="1100" b="1">
-                          <a:solidFill>
-                            <a:srgbClr val="222222"/>
-                          </a:solidFill>
-                          <a:latin typeface="Arial"/>
-                          <a:ea typeface="AppleGothic"/>
-                        </a:rPr>
-                        <a:t>FT-Transformer</a:t>
-                      </a:r>
-                    </a:p>
-                  </a:txBody>
-                  <a:tcPr anchor="ctr">
-                    <a:solidFill>
-                      <a:srgbClr val="FFFFFF"/>
-                    </a:solidFill>
-                  </a:tcPr>
-                </a:tc>
-                <a:tc>
-                  <a:txBody>
-                    <a:bodyPr/>
-                    <a:lstStyle/>
-                    <a:p>
-                      <a:pPr algn="ctr"/>
-                      <a:r>
-                        <a:rPr sz="1100" b="0">
-                          <a:solidFill>
-                            <a:srgbClr val="222222"/>
-                          </a:solidFill>
-                          <a:latin typeface="Arial"/>
-                          <a:ea typeface="AppleGothic"/>
-                        </a:rPr>
-                        <a:t>.115</a:t>
-                      </a:r>
-                    </a:p>
-                  </a:txBody>
-                  <a:tcPr anchor="ctr">
-                    <a:solidFill>
-                      <a:srgbClr val="FFFFFF"/>
-                    </a:solidFill>
-                  </a:tcPr>
-                </a:tc>
-                <a:tc>
-                  <a:txBody>
-                    <a:bodyPr/>
-                    <a:lstStyle/>
-                    <a:p>
-                      <a:pPr algn="ctr"/>
-                      <a:r>
-                        <a:rPr sz="1100" b="0">
-                          <a:solidFill>
-                            <a:srgbClr val="222222"/>
-                          </a:solidFill>
-                          <a:latin typeface="Arial"/>
-                          <a:ea typeface="AppleGothic"/>
-                        </a:rPr>
-                        <a:t>1.005</a:t>
-                      </a:r>
-                    </a:p>
-                  </a:txBody>
-                  <a:tcPr anchor="ctr">
-                    <a:solidFill>
-                      <a:srgbClr val="FFFFFF"/>
-                    </a:solidFill>
-                  </a:tcPr>
-                </a:tc>
-                <a:tc>
-                  <a:txBody>
-                    <a:bodyPr/>
-                    <a:lstStyle/>
-                    <a:p>
-                      <a:pPr algn="ctr"/>
-                      <a:r>
-                        <a:rPr sz="1100" b="0">
-                          <a:solidFill>
-                            <a:srgbClr val="222222"/>
-                          </a:solidFill>
-                          <a:latin typeface="Arial"/>
-                          <a:ea typeface="AppleGothic"/>
-                        </a:rPr>
-                        <a:t>−2.010</a:t>
-                      </a:r>
-                    </a:p>
-                  </a:txBody>
-                  <a:tcPr anchor="ctr">
-                    <a:solidFill>
-                      <a:srgbClr val="FFFFFF"/>
-                    </a:solidFill>
-                  </a:tcPr>
-                </a:tc>
-                <a:tc>
-                  <a:txBody>
-                    <a:bodyPr/>
-                    <a:lstStyle/>
-                    <a:p>
-                      <a:pPr algn="ctr"/>
-                      <a:r>
-                        <a:rPr sz="1100" b="0">
-                          <a:solidFill>
-                            <a:srgbClr val="222222"/>
-                          </a:solidFill>
-                          <a:latin typeface="Arial"/>
-                          <a:ea typeface="AppleGothic"/>
-                        </a:rPr>
-                        <a:t>7/9</a:t>
-                      </a:r>
-                    </a:p>
-                  </a:txBody>
-                  <a:tcPr anchor="ctr">
-                    <a:solidFill>
-                      <a:srgbClr val="FFFFFF"/>
-                    </a:solidFill>
-                  </a:tcPr>
-                </a:tc>
-              </a:tr>
-              <a:tr h="523875">
-                <a:tc>
-                  <a:txBody>
-                    <a:bodyPr/>
-                    <a:lstStyle/>
-                    <a:p>
-                      <a:pPr algn="l"/>
-                      <a:r>
-                        <a:rPr sz="1100" b="1">
-                          <a:solidFill>
-                            <a:srgbClr val="222222"/>
-                          </a:solidFill>
-                          <a:latin typeface="Arial"/>
-                          <a:ea typeface="AppleGothic"/>
-                        </a:rPr>
-                        <a:t>plain MLP</a:t>
-                      </a:r>
-                    </a:p>
-                  </a:txBody>
-                  <a:tcPr anchor="ctr">
-                    <a:solidFill>
-                      <a:srgbClr val="F5F5F5"/>
-                    </a:solidFill>
-                  </a:tcPr>
-                </a:tc>
-                <a:tc>
-                  <a:txBody>
-                    <a:bodyPr/>
-                    <a:lstStyle/>
-                    <a:p>
-                      <a:pPr algn="ctr"/>
-                      <a:r>
-                        <a:rPr sz="1100" b="0">
-                          <a:solidFill>
-                            <a:srgbClr val="222222"/>
-                          </a:solidFill>
-                          <a:latin typeface="Arial"/>
-                          <a:ea typeface="AppleGothic"/>
-                        </a:rPr>
-                        <a:t>.093</a:t>
-                      </a:r>
-                    </a:p>
-                  </a:txBody>
-                  <a:tcPr anchor="ctr">
-                    <a:solidFill>
-                      <a:srgbClr val="F5F5F5"/>
-                    </a:solidFill>
-                  </a:tcPr>
-                </a:tc>
-                <a:tc>
-                  <a:txBody>
-                    <a:bodyPr/>
-                    <a:lstStyle/>
-                    <a:p>
-                      <a:pPr algn="ctr"/>
-                      <a:r>
-                        <a:rPr sz="1100" b="0">
-                          <a:solidFill>
-                            <a:srgbClr val="222222"/>
-                          </a:solidFill>
-                          <a:latin typeface="Arial"/>
-                          <a:ea typeface="AppleGothic"/>
-                        </a:rPr>
-                        <a:t>1.007</a:t>
-                      </a:r>
-                    </a:p>
-                  </a:txBody>
-                  <a:tcPr anchor="ctr">
-                    <a:solidFill>
-                      <a:srgbClr val="F5F5F5"/>
-                    </a:solidFill>
-                  </a:tcPr>
-                </a:tc>
-                <a:tc>
-                  <a:txBody>
-                    <a:bodyPr/>
-                    <a:lstStyle/>
-                    <a:p>
-                      <a:pPr algn="ctr"/>
-                      <a:r>
-                        <a:rPr sz="1100" b="0">
-                          <a:solidFill>
-                            <a:srgbClr val="222222"/>
-                          </a:solidFill>
-                          <a:latin typeface="Arial"/>
-                          <a:ea typeface="AppleGothic"/>
-                        </a:rPr>
-                        <a:t>−2.140</a:t>
-                      </a:r>
-                    </a:p>
-                  </a:txBody>
-                  <a:tcPr anchor="ctr">
-                    <a:solidFill>
-                      <a:srgbClr val="F5F5F5"/>
-                    </a:solidFill>
-                  </a:tcPr>
-                </a:tc>
-                <a:tc>
-                  <a:txBody>
-                    <a:bodyPr/>
-                    <a:lstStyle/>
-                    <a:p>
-                      <a:pPr algn="ctr"/>
-                      <a:r>
-                        <a:rPr sz="1100" b="0">
-                          <a:solidFill>
-                            <a:srgbClr val="222222"/>
-                          </a:solidFill>
-                          <a:latin typeface="Arial"/>
-                          <a:ea typeface="AppleGothic"/>
-                        </a:rPr>
-                        <a:t>6/9</a:t>
-                      </a:r>
-                    </a:p>
-                  </a:txBody>
-                  <a:tcPr anchor="ctr">
-                    <a:solidFill>
-                      <a:srgbClr val="F5F5F5"/>
-                    </a:solidFill>
-                  </a:tcPr>
-                </a:tc>
-              </a:tr>
-              <a:tr h="523875">
-                <a:tc>
-                  <a:txBody>
-                    <a:bodyPr/>
-                    <a:lstStyle/>
-                    <a:p>
-                      <a:pPr algn="l"/>
-                      <a:r>
-                        <a:rPr sz="1100" b="1">
-                          <a:solidFill>
-                            <a:srgbClr val="222222"/>
-                          </a:solidFill>
-                          <a:latin typeface="Arial"/>
-                          <a:ea typeface="AppleGothic"/>
-                        </a:rPr>
-                        <a:t>GroupDRO</a:t>
-                      </a:r>
-                    </a:p>
-                  </a:txBody>
-                  <a:tcPr anchor="ctr">
-                    <a:solidFill>
-                      <a:srgbClr val="FFFFFF"/>
-                    </a:solidFill>
-                  </a:tcPr>
-                </a:tc>
-                <a:tc>
-                  <a:txBody>
-                    <a:bodyPr/>
-                    <a:lstStyle/>
-                    <a:p>
-                      <a:pPr algn="ctr"/>
-                      <a:r>
-                        <a:rPr sz="1100" b="0">
-                          <a:solidFill>
-                            <a:srgbClr val="222222"/>
-                          </a:solidFill>
-                          <a:latin typeface="Arial"/>
-                          <a:ea typeface="AppleGothic"/>
-                        </a:rPr>
-                        <a:t>.011</a:t>
-                      </a:r>
-                    </a:p>
-                  </a:txBody>
-                  <a:tcPr anchor="ctr">
-                    <a:solidFill>
-                      <a:srgbClr val="FFFFFF"/>
-                    </a:solidFill>
-                  </a:tcPr>
-                </a:tc>
-                <a:tc>
-                  <a:txBody>
-                    <a:bodyPr/>
-                    <a:lstStyle/>
-                    <a:p>
-                      <a:pPr algn="ctr"/>
-                      <a:r>
-                        <a:rPr sz="1100" b="0">
-                          <a:solidFill>
-                            <a:srgbClr val="222222"/>
-                          </a:solidFill>
-                          <a:latin typeface="Arial"/>
-                          <a:ea typeface="AppleGothic"/>
-                        </a:rPr>
-                        <a:t>.998</a:t>
-                      </a:r>
-                    </a:p>
-                  </a:txBody>
-                  <a:tcPr anchor="ctr">
-                    <a:solidFill>
-                      <a:srgbClr val="FFFFFF"/>
-                    </a:solidFill>
-                  </a:tcPr>
-                </a:tc>
-                <a:tc>
-                  <a:txBody>
-                    <a:bodyPr/>
-                    <a:lstStyle/>
-                    <a:p>
-                      <a:pPr algn="ctr"/>
-                      <a:r>
-                        <a:rPr sz="1100" b="0">
-                          <a:solidFill>
-                            <a:srgbClr val="222222"/>
-                          </a:solidFill>
-                          <a:latin typeface="Arial"/>
-                          <a:ea typeface="AppleGothic"/>
-                        </a:rPr>
-                        <a:t>−2.057</a:t>
-                      </a:r>
-                    </a:p>
-                  </a:txBody>
-                  <a:tcPr anchor="ctr">
-                    <a:solidFill>
-                      <a:srgbClr val="FFFFFF"/>
-                    </a:solidFill>
-                  </a:tcPr>
-                </a:tc>
-                <a:tc>
-                  <a:txBody>
-                    <a:bodyPr/>
-                    <a:lstStyle/>
-                    <a:p>
-                      <a:pPr algn="ctr"/>
-                      <a:r>
-                        <a:rPr sz="1100" b="0">
-                          <a:solidFill>
-                            <a:srgbClr val="222222"/>
-                          </a:solidFill>
-                          <a:latin typeface="Arial"/>
-                          <a:ea typeface="AppleGothic"/>
-                        </a:rPr>
-                        <a:t>5/9</a:t>
-                      </a:r>
-                    </a:p>
-                  </a:txBody>
-                  <a:tcPr anchor="ctr">
-                    <a:solidFill>
-                      <a:srgbClr val="FFFFFF"/>
-                    </a:solidFill>
-                  </a:tcPr>
-                </a:tc>
-              </a:tr>
-            </a:tbl>
-          </a:graphicData>
-        </a:graphic>
-      </p:graphicFrame>
-      <p:sp>
-        <p:nvSpPr>
-          <p:cNvPr id="7" name="Rectangle 6"/>
-          <p:cNvSpPr/>
-          <p:nvPr/>
-        </p:nvSpPr>
-        <p:spPr>
-          <a:xfrm>
-            <a:off x="7810500" y="914400"/>
-            <a:ext cx="3905250" cy="1428750"/>
-          </a:xfrm>
-          <a:prstGeom prst="rect">
-            <a:avLst/>
-          </a:prstGeom>
-          <a:solidFill>
-            <a:srgbClr val="E8F1F8"/>
-          </a:solidFill>
-          <a:ln w="15875">
-            <a:solidFill>
-              <a:srgbClr val="0072B2"/>
-            </a:solidFill>
-          </a:ln>
-        </p:spPr>
-        <p:style>
-          <a:lnRef idx="1">
-            <a:schemeClr val="accent1"/>
-          </a:lnRef>
-          <a:fillRef idx="3">
-            <a:schemeClr val="accent1"/>
-          </a:fillRef>
-          <a:effectRef idx="2">
-            <a:schemeClr val="accent1"/>
-          </a:effectRef>
-          <a:fontRef idx="minor">
-            <a:schemeClr val="lt1"/>
-          </a:fontRef>
-        </p:style>
-        <p:txBody>
-          <a:bodyPr rtlCol="0" anchor="ctr"/>
-          <a:lstStyle/>
-          <a:p>
-            <a:pPr algn="ctr"/>
-          </a:p>
-        </p:txBody>
-      </p:sp>
-      <p:sp>
-        <p:nvSpPr>
-          <p:cNvPr id="8" name="TextBox 7"/>
-          <p:cNvSpPr txBox="1"/>
-          <p:nvPr/>
-        </p:nvSpPr>
-        <p:spPr>
-          <a:xfrm>
-            <a:off x="8001000" y="1066800"/>
-            <a:ext cx="3524250" cy="266700"/>
-          </a:xfrm>
-          <a:prstGeom prst="rect">
-            <a:avLst/>
-          </a:prstGeom>
-          <a:noFill/>
-        </p:spPr>
-        <p:txBody>
-          <a:bodyPr wrap="square">
-            <a:spAutoFit/>
-          </a:bodyPr>
-          <a:lstStyle/>
-          <a:p>
-            <a:pPr algn="ctr"/>
-            <a:r>
-              <a:rPr sz="1500" b="1">
-                <a:solidFill>
-                  <a:srgbClr val="0072B2"/>
-                </a:solidFill>
-                <a:latin typeface="Arial"/>
-                <a:ea typeface="AppleGothic"/>
-              </a:rPr>
-              <a:t>관찰된 붕괴 완화</a:t>
-            </a:r>
-          </a:p>
-        </p:txBody>
-      </p:sp>
-      <p:sp>
-        <p:nvSpPr>
-          <p:cNvPr id="9" name="TextBox 8"/>
-          <p:cNvSpPr txBox="1"/>
-          <p:nvPr/>
-        </p:nvSpPr>
-        <p:spPr>
-          <a:xfrm>
-            <a:off x="8001000" y="1466850"/>
-            <a:ext cx="3524250" cy="666750"/>
-          </a:xfrm>
-          <a:prstGeom prst="rect">
-            <a:avLst/>
-          </a:prstGeom>
-          <a:noFill/>
-        </p:spPr>
-        <p:txBody>
-          <a:bodyPr wrap="square">
-            <a:spAutoFit/>
-          </a:bodyPr>
-          <a:lstStyle/>
-          <a:p>
-            <a:pPr algn="ctr"/>
-            <a:r>
-              <a:rPr sz="1300" b="1">
-                <a:solidFill>
-                  <a:srgbClr val="222222"/>
-                </a:solidFill>
-                <a:latin typeface="Arial"/>
-                <a:ea typeface="AppleGothic"/>
-              </a:rPr>
-              <a:t>가장 작은 SD</a:t>
-            </a:r>
-          </a:p>
-          <a:p>
-            <a:pPr algn="ctr"/>
-            <a:r>
-              <a:rPr sz="1300" b="1">
-                <a:solidFill>
-                  <a:srgbClr val="222222"/>
-                </a:solidFill>
-                <a:latin typeface="Arial"/>
-                <a:ea typeface="AppleGothic"/>
-              </a:rPr>
-              <a:t>가장 높은 최악 R²</a:t>
-            </a:r>
-          </a:p>
-          <a:p>
-            <a:pPr algn="ctr"/>
-            <a:r>
-              <a:rPr sz="1300" b="1">
-                <a:solidFill>
-                  <a:srgbClr val="222222"/>
-                </a:solidFill>
-                <a:latin typeface="Arial"/>
-                <a:ea typeface="AppleGothic"/>
-              </a:rPr>
-              <a:t>유일한 9/9 양의 R²</a:t>
-            </a:r>
-          </a:p>
-        </p:txBody>
-      </p:sp>
-      <p:sp>
-        <p:nvSpPr>
-          <p:cNvPr id="10" name="Rectangle 9"/>
-          <p:cNvSpPr/>
-          <p:nvPr/>
-        </p:nvSpPr>
-        <p:spPr>
-          <a:xfrm>
-            <a:off x="7810500" y="2628900"/>
-            <a:ext cx="3905250" cy="1428750"/>
-          </a:xfrm>
-          <a:prstGeom prst="rect">
-            <a:avLst/>
-          </a:prstGeom>
-          <a:solidFill>
-            <a:srgbClr val="FDF4E3"/>
-          </a:solidFill>
-          <a:ln w="15875">
-            <a:solidFill>
-              <a:srgbClr val="E69F00"/>
-            </a:solidFill>
-          </a:ln>
-        </p:spPr>
-        <p:style>
-          <a:lnRef idx="1">
-            <a:schemeClr val="accent1"/>
-          </a:lnRef>
-          <a:fillRef idx="3">
-            <a:schemeClr val="accent1"/>
-          </a:fillRef>
-          <a:effectRef idx="2">
-            <a:schemeClr val="accent1"/>
-          </a:effectRef>
-          <a:fontRef idx="minor">
-            <a:schemeClr val="lt1"/>
-          </a:fontRef>
-        </p:style>
-        <p:txBody>
-          <a:bodyPr rtlCol="0" anchor="ctr"/>
-          <a:lstStyle/>
-          <a:p>
-            <a:pPr algn="ctr"/>
-          </a:p>
-        </p:txBody>
-      </p:sp>
-      <p:sp>
-        <p:nvSpPr>
-          <p:cNvPr id="11" name="TextBox 10"/>
-          <p:cNvSpPr txBox="1"/>
-          <p:nvPr/>
-        </p:nvSpPr>
-        <p:spPr>
-          <a:xfrm>
-            <a:off x="8001000" y="2781300"/>
-            <a:ext cx="3524250" cy="266700"/>
-          </a:xfrm>
-          <a:prstGeom prst="rect">
-            <a:avLst/>
-          </a:prstGeom>
-          <a:noFill/>
-        </p:spPr>
-        <p:txBody>
-          <a:bodyPr wrap="square">
-            <a:spAutoFit/>
-          </a:bodyPr>
-          <a:lstStyle/>
-          <a:p>
-            <a:pPr algn="ctr"/>
-            <a:r>
-              <a:rPr sz="1500" b="1">
-                <a:solidFill>
-                  <a:srgbClr val="E69F00"/>
-                </a:solidFill>
-                <a:latin typeface="Arial"/>
-                <a:ea typeface="AppleGothic"/>
-              </a:rPr>
-              <a:t>통계적 경계</a:t>
-            </a:r>
-          </a:p>
-        </p:txBody>
-      </p:sp>
-      <p:sp>
-        <p:nvSpPr>
-          <p:cNvPr id="12" name="TextBox 11"/>
-          <p:cNvSpPr txBox="1"/>
-          <p:nvPr/>
-        </p:nvSpPr>
-        <p:spPr>
-          <a:xfrm>
-            <a:off x="8001000" y="3181350"/>
-            <a:ext cx="3524250" cy="666750"/>
-          </a:xfrm>
-          <a:prstGeom prst="rect">
-            <a:avLst/>
-          </a:prstGeom>
-          <a:noFill/>
-        </p:spPr>
-        <p:txBody>
-          <a:bodyPr wrap="square">
-            <a:spAutoFit/>
-          </a:bodyPr>
-          <a:lstStyle/>
-          <a:p>
-            <a:pPr algn="ctr"/>
-            <a:r>
-              <a:rPr sz="1200" b="1">
-                <a:solidFill>
-                  <a:srgbClr val="222222"/>
-                </a:solidFill>
-                <a:latin typeface="Arial"/>
-                <a:ea typeface="AppleGothic"/>
-              </a:rPr>
-              <a:t>Engression 대비 MAD p=.0391</a:t>
-            </a:r>
-          </a:p>
-          <a:p>
-            <a:pPr algn="ctr"/>
-            <a:r>
-              <a:rPr sz="1200" b="1">
-                <a:solidFill>
-                  <a:srgbClr val="222222"/>
-                </a:solidFill>
-                <a:latin typeface="Arial"/>
-                <a:ea typeface="AppleGothic"/>
-              </a:rPr>
-              <a:t>8모델 Holm 보정 q=.2734</a:t>
-            </a:r>
-          </a:p>
-          <a:p>
-            <a:pPr algn="ctr"/>
-            <a:r>
-              <a:rPr sz="1200" b="1">
-                <a:solidFill>
-                  <a:srgbClr val="222222"/>
-                </a:solidFill>
-                <a:latin typeface="Arial"/>
-                <a:ea typeface="AppleGothic"/>
-              </a:rPr>
-              <a:t>→ 전 모델 대비 확증은 아님</a:t>
-            </a:r>
-          </a:p>
-        </p:txBody>
-      </p:sp>
-      <p:sp>
-        <p:nvSpPr>
-          <p:cNvPr id="13" name="Rectangle 12"/>
-          <p:cNvSpPr/>
-          <p:nvPr/>
-        </p:nvSpPr>
-        <p:spPr>
-          <a:xfrm>
-            <a:off x="571500" y="4524375"/>
-            <a:ext cx="11049000" cy="876300"/>
-          </a:xfrm>
-          <a:prstGeom prst="rect">
-            <a:avLst/>
-          </a:prstGeom>
-          <a:solidFill>
-            <a:srgbClr val="E8F1F8"/>
-          </a:solidFill>
-          <a:ln w="15875">
-            <a:solidFill>
-              <a:srgbClr val="0072B2"/>
-            </a:solidFill>
-          </a:ln>
-        </p:spPr>
-        <p:style>
-          <a:lnRef idx="1">
-            <a:schemeClr val="accent1"/>
-          </a:lnRef>
-          <a:fillRef idx="3">
-            <a:schemeClr val="accent1"/>
-          </a:fillRef>
-          <a:effectRef idx="2">
-            <a:schemeClr val="accent1"/>
-          </a:effectRef>
-          <a:fontRef idx="minor">
-            <a:schemeClr val="lt1"/>
-          </a:fontRef>
-        </p:style>
-        <p:txBody>
-          <a:bodyPr rtlCol="0" anchor="ctr"/>
-          <a:lstStyle/>
-          <a:p>
-            <a:pPr algn="ctr"/>
-          </a:p>
-        </p:txBody>
-      </p:sp>
-      <p:sp>
-        <p:nvSpPr>
-          <p:cNvPr id="14" name="TextBox 13"/>
-          <p:cNvSpPr txBox="1"/>
-          <p:nvPr/>
-        </p:nvSpPr>
-        <p:spPr>
-          <a:xfrm>
-            <a:off x="809625" y="4657725"/>
-            <a:ext cx="10572750" cy="590550"/>
-          </a:xfrm>
-          <a:prstGeom prst="rect">
-            <a:avLst/>
-          </a:prstGeom>
-          <a:noFill/>
-        </p:spPr>
-        <p:txBody>
-          <a:bodyPr wrap="square">
-            <a:spAutoFit/>
-          </a:bodyPr>
-          <a:lstStyle/>
-          <a:p>
-            <a:pPr algn="ctr"/>
-            <a:r>
-              <a:rPr sz="1250" b="1">
-                <a:solidFill>
-                  <a:srgbClr val="222222"/>
-                </a:solidFill>
-                <a:latin typeface="Arial"/>
-                <a:ea typeface="AppleGothic"/>
-              </a:rPr>
-              <a:t>허용 주장: “현재 9개 retrospective 외삽 setting에서 PP-X는 심한 성능 붕괴가 덜 관찰됐다.”</a:t>
-            </a:r>
-          </a:p>
-          <a:p>
-            <a:pPr algn="ctr"/>
-            <a:r>
-              <a:rPr sz="1250" b="1">
-                <a:solidFill>
-                  <a:srgbClr val="222222"/>
-                </a:solidFill>
-                <a:latin typeface="Arial"/>
-                <a:ea typeface="AppleGothic"/>
-              </a:rPr>
-              <a:t>금지 주장: “모든 미래 데이터와 모든 모델에 대해 안정성 우월이 통계적으로 확증됐다.”</a:t>
-            </a:r>
-          </a:p>
-        </p:txBody>
-      </p:sp>
-      <p:sp>
-        <p:nvSpPr>
-          <p:cNvPr id="15" name="TextBox 14"/>
-          <p:cNvSpPr txBox="1"/>
-          <p:nvPr/>
-        </p:nvSpPr>
-        <p:spPr>
-          <a:xfrm>
-            <a:off x="666750" y="5810250"/>
-            <a:ext cx="10858500" cy="333375"/>
-          </a:xfrm>
-          <a:prstGeom prst="rect">
-            <a:avLst/>
-          </a:prstGeom>
-          <a:noFill/>
-        </p:spPr>
-        <p:txBody>
-          <a:bodyPr wrap="square">
-            <a:spAutoFit/>
-          </a:bodyPr>
-          <a:lstStyle/>
-          <a:p>
-            <a:pPr algn="ctr"/>
-            <a:r>
-              <a:rPr sz="1150" b="1">
-                <a:solidFill>
-                  <a:srgbClr val="666666"/>
-                </a:solidFill>
-                <a:latin typeface="Arial"/>
-                <a:ea typeface="AppleGothic"/>
-              </a:rPr>
-              <a:t>5-seed는 optimizer 재학습 기술통계다. n=5 양측 exact 검정 최소 p=.0625이므로 독립적인 안정성 확증으로 쓰지 않는다.</a:t>
-            </a:r>
-          </a:p>
-        </p:txBody>
-      </p:sp>
-      <p:sp>
-        <p:nvSpPr>
-          <p:cNvPr id="16" name="TextBox 15"/>
-          <p:cNvSpPr txBox="1"/>
-          <p:nvPr/>
-        </p:nvSpPr>
-        <p:spPr>
-          <a:xfrm>
-            <a:off x="10858500" y="6419850"/>
-            <a:ext cx="838200" cy="171450"/>
-          </a:xfrm>
-          <a:prstGeom prst="rect">
-            <a:avLst/>
-          </a:prstGeom>
-          <a:noFill/>
-        </p:spPr>
-        <p:txBody>
-          <a:bodyPr wrap="square">
-            <a:spAutoFit/>
-          </a:bodyPr>
-          <a:lstStyle/>
-          <a:p>
-            <a:pPr algn="r"/>
-            <a:r>
-              <a:rPr sz="900" b="1">
-                <a:solidFill>
-                  <a:srgbClr val="666666"/>
-                </a:solidFill>
-                <a:latin typeface="Arial"/>
-                <a:ea typeface="AppleGothic"/>
-              </a:rPr>
-              <a:t>17/18</a:t>
             </a:r>
           </a:p>
         </p:txBody>

</xml_diff>

<commit_message>
Define executor candidates on gate slide
Co-authored-by: Cursor <cursoragent@cursor.com>
</commit_message>
<xml_diff>
--- a/ppt/PP-X_Final_Research_20min.pptx
+++ b/ppt/PP-X_Final_Research_20min.pptx
@@ -24477,6 +24477,952 @@
           </a:p>
         </p:txBody>
       </p:sp>
+      <p:sp>
+        <p:nvSpPr>
+          <p:cNvPr id="29" name="TextBox 28"/>
+          <p:cNvSpPr txBox="1"/>
+          <p:nvPr/>
+        </p:nvSpPr>
+        <p:spPr>
+          <a:xfrm>
+            <a:off x="457200" y="4333875"/>
+            <a:ext cx="11277600" cy="209550"/>
+          </a:xfrm>
+          <a:prstGeom prst="rect">
+            <a:avLst/>
+          </a:prstGeom>
+          <a:noFill/>
+        </p:spPr>
+        <p:txBody>
+          <a:bodyPr wrap="square">
+            <a:spAutoFit/>
+          </a:bodyPr>
+          <a:lstStyle/>
+          <a:p>
+            <a:pPr algn="l"/>
+            <a:r>
+              <a:rPr sz="1150" b="1">
+                <a:solidFill>
+                  <a:srgbClr val="222222"/>
+                </a:solidFill>
+                <a:latin typeface="Arial"/>
+                <a:ea typeface="AppleGothic"/>
+              </a:rPr>
+              <a:t>후보 뜻 — 무엇을 바꾸는가</a:t>
+            </a:r>
+          </a:p>
+        </p:txBody>
+      </p:sp>
+      <p:sp>
+        <p:nvSpPr>
+          <p:cNvPr id="30" name="Rounded Rectangle 29"/>
+          <p:cNvSpPr/>
+          <p:nvPr/>
+        </p:nvSpPr>
+        <p:spPr>
+          <a:xfrm>
+            <a:off x="457200" y="4591050"/>
+            <a:ext cx="2628900" cy="647700"/>
+          </a:xfrm>
+          <a:prstGeom prst="roundRect">
+            <a:avLst/>
+          </a:prstGeom>
+          <a:solidFill>
+            <a:srgbClr val="E8F1F8"/>
+          </a:solidFill>
+          <a:ln w="15875">
+            <a:solidFill>
+              <a:srgbClr val="0072B2"/>
+            </a:solidFill>
+          </a:ln>
+        </p:spPr>
+        <p:style>
+          <a:lnRef idx="1">
+            <a:schemeClr val="accent1"/>
+          </a:lnRef>
+          <a:fillRef idx="3">
+            <a:schemeClr val="accent1"/>
+          </a:fillRef>
+          <a:effectRef idx="2">
+            <a:schemeClr val="accent1"/>
+          </a:effectRef>
+          <a:fontRef idx="minor">
+            <a:schemeClr val="lt1"/>
+          </a:fontRef>
+        </p:style>
+        <p:txBody>
+          <a:bodyPr rtlCol="0" anchor="ctr"/>
+          <a:lstStyle/>
+          <a:p>
+            <a:pPr algn="ctr"/>
+          </a:p>
+        </p:txBody>
+      </p:sp>
+      <p:sp>
+        <p:nvSpPr>
+          <p:cNvPr id="31" name="TextBox 30"/>
+          <p:cNvSpPr txBox="1"/>
+          <p:nvPr/>
+        </p:nvSpPr>
+        <p:spPr>
+          <a:xfrm>
+            <a:off x="533400" y="4648200"/>
+            <a:ext cx="2476500" cy="171450"/>
+          </a:xfrm>
+          <a:prstGeom prst="rect">
+            <a:avLst/>
+          </a:prstGeom>
+          <a:noFill/>
+        </p:spPr>
+        <p:txBody>
+          <a:bodyPr wrap="square">
+            <a:spAutoFit/>
+          </a:bodyPr>
+          <a:lstStyle/>
+          <a:p>
+            <a:pPr algn="ctr"/>
+            <a:r>
+              <a:rPr sz="1050" b="1">
+                <a:solidFill>
+                  <a:srgbClr val="0072B2"/>
+                </a:solidFill>
+                <a:latin typeface="Arial"/>
+                <a:ea typeface="AppleGothic"/>
+              </a:rPr>
+              <a:t>prior-only</a:t>
+            </a:r>
+          </a:p>
+        </p:txBody>
+      </p:sp>
+      <p:sp>
+        <p:nvSpPr>
+          <p:cNvPr id="32" name="TextBox 31"/>
+          <p:cNvSpPr txBox="1"/>
+          <p:nvPr/>
+        </p:nvSpPr>
+        <p:spPr>
+          <a:xfrm>
+            <a:off x="533400" y="4838700"/>
+            <a:ext cx="2476500" cy="323850"/>
+          </a:xfrm>
+          <a:prstGeom prst="rect">
+            <a:avLst/>
+          </a:prstGeom>
+          <a:noFill/>
+        </p:spPr>
+        <p:txBody>
+          <a:bodyPr wrap="square">
+            <a:spAutoFit/>
+          </a:bodyPr>
+          <a:lstStyle/>
+          <a:p>
+            <a:pPr algn="ctr"/>
+            <a:r>
+              <a:rPr sz="950" b="0">
+                <a:solidFill>
+                  <a:srgbClr val="222222"/>
+                </a:solidFill>
+                <a:latin typeface="Arial"/>
+                <a:ea typeface="AppleGothic"/>
+              </a:rPr>
+              <a:t>prior만 사용</a:t>
+            </a:r>
+          </a:p>
+          <a:p>
+            <a:pPr algn="ctr"/>
+            <a:r>
+              <a:rPr sz="950" b="0">
+                <a:solidFill>
+                  <a:srgbClr val="222222"/>
+                </a:solidFill>
+                <a:latin typeface="Arial"/>
+                <a:ea typeface="AppleGothic"/>
+              </a:rPr>
+              <a:t>residual 없음</a:t>
+            </a:r>
+          </a:p>
+        </p:txBody>
+      </p:sp>
+      <p:sp>
+        <p:nvSpPr>
+          <p:cNvPr id="33" name="Rounded Rectangle 32"/>
+          <p:cNvSpPr/>
+          <p:nvPr/>
+        </p:nvSpPr>
+        <p:spPr>
+          <a:xfrm>
+            <a:off x="3295650" y="4591050"/>
+            <a:ext cx="2628900" cy="647700"/>
+          </a:xfrm>
+          <a:prstGeom prst="roundRect">
+            <a:avLst/>
+          </a:prstGeom>
+          <a:solidFill>
+            <a:srgbClr val="E8F1F8"/>
+          </a:solidFill>
+          <a:ln w="15875">
+            <a:solidFill>
+              <a:srgbClr val="0072B2"/>
+            </a:solidFill>
+          </a:ln>
+        </p:spPr>
+        <p:style>
+          <a:lnRef idx="1">
+            <a:schemeClr val="accent1"/>
+          </a:lnRef>
+          <a:fillRef idx="3">
+            <a:schemeClr val="accent1"/>
+          </a:fillRef>
+          <a:effectRef idx="2">
+            <a:schemeClr val="accent1"/>
+          </a:effectRef>
+          <a:fontRef idx="minor">
+            <a:schemeClr val="lt1"/>
+          </a:fontRef>
+        </p:style>
+        <p:txBody>
+          <a:bodyPr rtlCol="0" anchor="ctr"/>
+          <a:lstStyle/>
+          <a:p>
+            <a:pPr algn="ctr"/>
+          </a:p>
+        </p:txBody>
+      </p:sp>
+      <p:sp>
+        <p:nvSpPr>
+          <p:cNvPr id="34" name="TextBox 33"/>
+          <p:cNvSpPr txBox="1"/>
+          <p:nvPr/>
+        </p:nvSpPr>
+        <p:spPr>
+          <a:xfrm>
+            <a:off x="3371850" y="4648200"/>
+            <a:ext cx="2476500" cy="171450"/>
+          </a:xfrm>
+          <a:prstGeom prst="rect">
+            <a:avLst/>
+          </a:prstGeom>
+          <a:noFill/>
+        </p:spPr>
+        <p:txBody>
+          <a:bodyPr wrap="square">
+            <a:spAutoFit/>
+          </a:bodyPr>
+          <a:lstStyle/>
+          <a:p>
+            <a:pPr algn="ctr"/>
+            <a:r>
+              <a:rPr sz="1050" b="1">
+                <a:solidFill>
+                  <a:srgbClr val="0072B2"/>
+                </a:solidFill>
+                <a:latin typeface="Arial"/>
+                <a:ea typeface="AppleGothic"/>
+              </a:rPr>
+              <a:t>unbounded</a:t>
+            </a:r>
+          </a:p>
+        </p:txBody>
+      </p:sp>
+      <p:sp>
+        <p:nvSpPr>
+          <p:cNvPr id="35" name="TextBox 34"/>
+          <p:cNvSpPr txBox="1"/>
+          <p:nvPr/>
+        </p:nvSpPr>
+        <p:spPr>
+          <a:xfrm>
+            <a:off x="3371850" y="4838700"/>
+            <a:ext cx="2476500" cy="323850"/>
+          </a:xfrm>
+          <a:prstGeom prst="rect">
+            <a:avLst/>
+          </a:prstGeom>
+          <a:noFill/>
+        </p:spPr>
+        <p:txBody>
+          <a:bodyPr wrap="square">
+            <a:spAutoFit/>
+          </a:bodyPr>
+          <a:lstStyle/>
+          <a:p>
+            <a:pPr algn="ctr"/>
+            <a:r>
+              <a:rPr sz="950" b="0">
+                <a:solidFill>
+                  <a:srgbClr val="222222"/>
+                </a:solidFill>
+                <a:latin typeface="Arial"/>
+                <a:ea typeface="AppleGothic"/>
+              </a:rPr>
+              <a:t>prior + r(z)</a:t>
+            </a:r>
+          </a:p>
+          <a:p>
+            <a:pPr algn="ctr"/>
+            <a:r>
+              <a:rPr sz="950" b="0">
+                <a:solidFill>
+                  <a:srgbClr val="222222"/>
+                </a:solidFill>
+                <a:latin typeface="Arial"/>
+                <a:ea typeface="AppleGothic"/>
+              </a:rPr>
+              <a:t>수정폭 제한 없음</a:t>
+            </a:r>
+          </a:p>
+        </p:txBody>
+      </p:sp>
+      <p:sp>
+        <p:nvSpPr>
+          <p:cNvPr id="36" name="Rounded Rectangle 35"/>
+          <p:cNvSpPr/>
+          <p:nvPr/>
+        </p:nvSpPr>
+        <p:spPr>
+          <a:xfrm>
+            <a:off x="6134100" y="4591050"/>
+            <a:ext cx="2628900" cy="647700"/>
+          </a:xfrm>
+          <a:prstGeom prst="roundRect">
+            <a:avLst/>
+          </a:prstGeom>
+          <a:solidFill>
+            <a:srgbClr val="E8F1F8"/>
+          </a:solidFill>
+          <a:ln w="15875">
+            <a:solidFill>
+              <a:srgbClr val="0072B2"/>
+            </a:solidFill>
+          </a:ln>
+        </p:spPr>
+        <p:style>
+          <a:lnRef idx="1">
+            <a:schemeClr val="accent1"/>
+          </a:lnRef>
+          <a:fillRef idx="3">
+            <a:schemeClr val="accent1"/>
+          </a:fillRef>
+          <a:effectRef idx="2">
+            <a:schemeClr val="accent1"/>
+          </a:effectRef>
+          <a:fontRef idx="minor">
+            <a:schemeClr val="lt1"/>
+          </a:fontRef>
+        </p:style>
+        <p:txBody>
+          <a:bodyPr rtlCol="0" anchor="ctr"/>
+          <a:lstStyle/>
+          <a:p>
+            <a:pPr algn="ctr"/>
+          </a:p>
+        </p:txBody>
+      </p:sp>
+      <p:sp>
+        <p:nvSpPr>
+          <p:cNvPr id="37" name="TextBox 36"/>
+          <p:cNvSpPr txBox="1"/>
+          <p:nvPr/>
+        </p:nvSpPr>
+        <p:spPr>
+          <a:xfrm>
+            <a:off x="6210300" y="4648200"/>
+            <a:ext cx="2476500" cy="171450"/>
+          </a:xfrm>
+          <a:prstGeom prst="rect">
+            <a:avLst/>
+          </a:prstGeom>
+          <a:noFill/>
+        </p:spPr>
+        <p:txBody>
+          <a:bodyPr wrap="square">
+            <a:spAutoFit/>
+          </a:bodyPr>
+          <a:lstStyle/>
+          <a:p>
+            <a:pPr algn="ctr"/>
+            <a:r>
+              <a:rPr sz="1050" b="1">
+                <a:solidFill>
+                  <a:srgbClr val="0072B2"/>
+                </a:solidFill>
+                <a:latin typeface="Arial"/>
+                <a:ea typeface="AppleGothic"/>
+              </a:rPr>
+              <a:t>bounded</a:t>
+            </a:r>
+          </a:p>
+        </p:txBody>
+      </p:sp>
+      <p:sp>
+        <p:nvSpPr>
+          <p:cNvPr id="38" name="TextBox 37"/>
+          <p:cNvSpPr txBox="1"/>
+          <p:nvPr/>
+        </p:nvSpPr>
+        <p:spPr>
+          <a:xfrm>
+            <a:off x="6210300" y="4838700"/>
+            <a:ext cx="2476500" cy="323850"/>
+          </a:xfrm>
+          <a:prstGeom prst="rect">
+            <a:avLst/>
+          </a:prstGeom>
+          <a:noFill/>
+        </p:spPr>
+        <p:txBody>
+          <a:bodyPr wrap="square">
+            <a:spAutoFit/>
+          </a:bodyPr>
+          <a:lstStyle/>
+          <a:p>
+            <a:pPr algn="ctr"/>
+            <a:r>
+              <a:rPr sz="950" b="0">
+                <a:solidFill>
+                  <a:srgbClr val="222222"/>
+                </a:solidFill>
+                <a:latin typeface="Arial"/>
+                <a:ea typeface="AppleGothic"/>
+              </a:rPr>
+              <a:t>고정 B로</a:t>
+            </a:r>
+          </a:p>
+          <a:p>
+            <a:pPr algn="ctr"/>
+            <a:r>
+              <a:rPr sz="950" b="0">
+                <a:solidFill>
+                  <a:srgbClr val="222222"/>
+                </a:solidFill>
+                <a:latin typeface="Arial"/>
+                <a:ea typeface="AppleGothic"/>
+              </a:rPr>
+              <a:t>residual 포화</a:t>
+            </a:r>
+          </a:p>
+        </p:txBody>
+      </p:sp>
+      <p:sp>
+        <p:nvSpPr>
+          <p:cNvPr id="39" name="Rounded Rectangle 38"/>
+          <p:cNvSpPr/>
+          <p:nvPr/>
+        </p:nvSpPr>
+        <p:spPr>
+          <a:xfrm>
+            <a:off x="8972550" y="4591050"/>
+            <a:ext cx="2628900" cy="647700"/>
+          </a:xfrm>
+          <a:prstGeom prst="roundRect">
+            <a:avLst/>
+          </a:prstGeom>
+          <a:solidFill>
+            <a:srgbClr val="E8F1F8"/>
+          </a:solidFill>
+          <a:ln w="15875">
+            <a:solidFill>
+              <a:srgbClr val="0072B2"/>
+            </a:solidFill>
+          </a:ln>
+        </p:spPr>
+        <p:style>
+          <a:lnRef idx="1">
+            <a:schemeClr val="accent1"/>
+          </a:lnRef>
+          <a:fillRef idx="3">
+            <a:schemeClr val="accent1"/>
+          </a:fillRef>
+          <a:effectRef idx="2">
+            <a:schemeClr val="accent1"/>
+          </a:effectRef>
+          <a:fontRef idx="minor">
+            <a:schemeClr val="lt1"/>
+          </a:fontRef>
+        </p:style>
+        <p:txBody>
+          <a:bodyPr rtlCol="0" anchor="ctr"/>
+          <a:lstStyle/>
+          <a:p>
+            <a:pPr algn="ctr"/>
+          </a:p>
+        </p:txBody>
+      </p:sp>
+      <p:sp>
+        <p:nvSpPr>
+          <p:cNvPr id="40" name="TextBox 39"/>
+          <p:cNvSpPr txBox="1"/>
+          <p:nvPr/>
+        </p:nvSpPr>
+        <p:spPr>
+          <a:xfrm>
+            <a:off x="9048750" y="4648200"/>
+            <a:ext cx="2476500" cy="171450"/>
+          </a:xfrm>
+          <a:prstGeom prst="rect">
+            <a:avLst/>
+          </a:prstGeom>
+          <a:noFill/>
+        </p:spPr>
+        <p:txBody>
+          <a:bodyPr wrap="square">
+            <a:spAutoFit/>
+          </a:bodyPr>
+          <a:lstStyle/>
+          <a:p>
+            <a:pPr algn="ctr"/>
+            <a:r>
+              <a:rPr sz="1050" b="1">
+                <a:solidFill>
+                  <a:srgbClr val="0072B2"/>
+                </a:solidFill>
+                <a:latin typeface="Arial"/>
+                <a:ea typeface="AppleGothic"/>
+              </a:rPr>
+              <a:t>dual-scale</a:t>
+            </a:r>
+          </a:p>
+        </p:txBody>
+      </p:sp>
+      <p:sp>
+        <p:nvSpPr>
+          <p:cNvPr id="41" name="TextBox 40"/>
+          <p:cNvSpPr txBox="1"/>
+          <p:nvPr/>
+        </p:nvSpPr>
+        <p:spPr>
+          <a:xfrm>
+            <a:off x="9048750" y="4838700"/>
+            <a:ext cx="2476500" cy="323850"/>
+          </a:xfrm>
+          <a:prstGeom prst="rect">
+            <a:avLst/>
+          </a:prstGeom>
+          <a:noFill/>
+        </p:spPr>
+        <p:txBody>
+          <a:bodyPr wrap="square">
+            <a:spAutoFit/>
+          </a:bodyPr>
+          <a:lstStyle/>
+          <a:p>
+            <a:pPr algn="ctr"/>
+            <a:r>
+              <a:rPr sz="950" b="0">
+                <a:solidFill>
+                  <a:srgbClr val="222222"/>
+                </a:solidFill>
+                <a:latin typeface="Arial"/>
+                <a:ea typeface="AppleGothic"/>
+              </a:rPr>
+              <a:t>support에 따라</a:t>
+            </a:r>
+          </a:p>
+          <a:p>
+            <a:pPr algn="ctr"/>
+            <a:r>
+              <a:rPr sz="950" b="0">
+                <a:solidFill>
+                  <a:srgbClr val="222222"/>
+                </a:solidFill>
+                <a:latin typeface="Arial"/>
+                <a:ea typeface="AppleGothic"/>
+              </a:rPr>
+              <a:t>좁은/넓은 B 선택</a:t>
+            </a:r>
+          </a:p>
+        </p:txBody>
+      </p:sp>
+      <p:sp>
+        <p:nvSpPr>
+          <p:cNvPr id="42" name="Rounded Rectangle 41"/>
+          <p:cNvSpPr/>
+          <p:nvPr/>
+        </p:nvSpPr>
+        <p:spPr>
+          <a:xfrm>
+            <a:off x="457200" y="5391150"/>
+            <a:ext cx="3571875" cy="647700"/>
+          </a:xfrm>
+          <a:prstGeom prst="roundRect">
+            <a:avLst/>
+          </a:prstGeom>
+          <a:solidFill>
+            <a:srgbClr val="FDF4E3"/>
+          </a:solidFill>
+          <a:ln w="15875">
+            <a:solidFill>
+              <a:srgbClr val="E69F00"/>
+            </a:solidFill>
+          </a:ln>
+        </p:spPr>
+        <p:style>
+          <a:lnRef idx="1">
+            <a:schemeClr val="accent1"/>
+          </a:lnRef>
+          <a:fillRef idx="3">
+            <a:schemeClr val="accent1"/>
+          </a:fillRef>
+          <a:effectRef idx="2">
+            <a:schemeClr val="accent1"/>
+          </a:effectRef>
+          <a:fontRef idx="minor">
+            <a:schemeClr val="lt1"/>
+          </a:fontRef>
+        </p:style>
+        <p:txBody>
+          <a:bodyPr rtlCol="0" anchor="ctr"/>
+          <a:lstStyle/>
+          <a:p>
+            <a:pPr algn="ctr"/>
+          </a:p>
+        </p:txBody>
+      </p:sp>
+      <p:sp>
+        <p:nvSpPr>
+          <p:cNvPr id="43" name="TextBox 42"/>
+          <p:cNvSpPr txBox="1"/>
+          <p:nvPr/>
+        </p:nvSpPr>
+        <p:spPr>
+          <a:xfrm>
+            <a:off x="533400" y="5448300"/>
+            <a:ext cx="3419475" cy="171450"/>
+          </a:xfrm>
+          <a:prstGeom prst="rect">
+            <a:avLst/>
+          </a:prstGeom>
+          <a:noFill/>
+        </p:spPr>
+        <p:txBody>
+          <a:bodyPr wrap="square">
+            <a:spAutoFit/>
+          </a:bodyPr>
+          <a:lstStyle/>
+          <a:p>
+            <a:pPr algn="ctr"/>
+            <a:r>
+              <a:rPr sz="1050" b="1">
+                <a:solidFill>
+                  <a:srgbClr val="E69F00"/>
+                </a:solidFill>
+                <a:latin typeface="Arial"/>
+                <a:ea typeface="AppleGothic"/>
+              </a:rPr>
+              <a:t>transport</a:t>
+            </a:r>
+          </a:p>
+        </p:txBody>
+      </p:sp>
+      <p:sp>
+        <p:nvSpPr>
+          <p:cNvPr id="44" name="TextBox 43"/>
+          <p:cNvSpPr txBox="1"/>
+          <p:nvPr/>
+        </p:nvSpPr>
+        <p:spPr>
+          <a:xfrm>
+            <a:off x="533400" y="5638800"/>
+            <a:ext cx="3419475" cy="323850"/>
+          </a:xfrm>
+          <a:prstGeom prst="rect">
+            <a:avLst/>
+          </a:prstGeom>
+          <a:noFill/>
+        </p:spPr>
+        <p:txBody>
+          <a:bodyPr wrap="square">
+            <a:spAutoFit/>
+          </a:bodyPr>
+          <a:lstStyle/>
+          <a:p>
+            <a:pPr algn="ctr"/>
+            <a:r>
+              <a:rPr sz="950" b="0">
+                <a:solidFill>
+                  <a:srgbClr val="222222"/>
+                </a:solidFill>
+                <a:latin typeface="Arial"/>
+                <a:ea typeface="AppleGothic"/>
+              </a:rPr>
+              <a:t>regime별 출력</a:t>
+            </a:r>
+          </a:p>
+          <a:p>
+            <a:pPr algn="ctr"/>
+            <a:r>
+              <a:rPr sz="950" b="0">
+                <a:solidFill>
+                  <a:srgbClr val="222222"/>
+                </a:solidFill>
+                <a:latin typeface="Arial"/>
+                <a:ea typeface="AppleGothic"/>
+              </a:rPr>
+              <a:t>scale·offset 보정</a:t>
+            </a:r>
+          </a:p>
+        </p:txBody>
+      </p:sp>
+      <p:sp>
+        <p:nvSpPr>
+          <p:cNvPr id="45" name="Rounded Rectangle 44"/>
+          <p:cNvSpPr/>
+          <p:nvPr/>
+        </p:nvSpPr>
+        <p:spPr>
+          <a:xfrm>
+            <a:off x="4238625" y="5391150"/>
+            <a:ext cx="3571875" cy="647700"/>
+          </a:xfrm>
+          <a:prstGeom prst="roundRect">
+            <a:avLst/>
+          </a:prstGeom>
+          <a:solidFill>
+            <a:srgbClr val="FDF4E3"/>
+          </a:solidFill>
+          <a:ln w="15875">
+            <a:solidFill>
+              <a:srgbClr val="E69F00"/>
+            </a:solidFill>
+          </a:ln>
+        </p:spPr>
+        <p:style>
+          <a:lnRef idx="1">
+            <a:schemeClr val="accent1"/>
+          </a:lnRef>
+          <a:fillRef idx="3">
+            <a:schemeClr val="accent1"/>
+          </a:fillRef>
+          <a:effectRef idx="2">
+            <a:schemeClr val="accent1"/>
+          </a:effectRef>
+          <a:fontRef idx="minor">
+            <a:schemeClr val="lt1"/>
+          </a:fontRef>
+        </p:style>
+        <p:txBody>
+          <a:bodyPr rtlCol="0" anchor="ctr"/>
+          <a:lstStyle/>
+          <a:p>
+            <a:pPr algn="ctr"/>
+          </a:p>
+        </p:txBody>
+      </p:sp>
+      <p:sp>
+        <p:nvSpPr>
+          <p:cNvPr id="46" name="TextBox 45"/>
+          <p:cNvSpPr txBox="1"/>
+          <p:nvPr/>
+        </p:nvSpPr>
+        <p:spPr>
+          <a:xfrm>
+            <a:off x="4314825" y="5448300"/>
+            <a:ext cx="3419475" cy="171450"/>
+          </a:xfrm>
+          <a:prstGeom prst="rect">
+            <a:avLst/>
+          </a:prstGeom>
+          <a:noFill/>
+        </p:spPr>
+        <p:txBody>
+          <a:bodyPr wrap="square">
+            <a:spAutoFit/>
+          </a:bodyPr>
+          <a:lstStyle/>
+          <a:p>
+            <a:pPr algn="ctr"/>
+            <a:r>
+              <a:rPr sz="1050" b="1">
+                <a:solidFill>
+                  <a:srgbClr val="E69F00"/>
+                </a:solidFill>
+                <a:latin typeface="Arial"/>
+                <a:ea typeface="AppleGothic"/>
+              </a:rPr>
+              <a:t>history</a:t>
+            </a:r>
+          </a:p>
+        </p:txBody>
+      </p:sp>
+      <p:sp>
+        <p:nvSpPr>
+          <p:cNvPr id="47" name="TextBox 46"/>
+          <p:cNvSpPr txBox="1"/>
+          <p:nvPr/>
+        </p:nvSpPr>
+        <p:spPr>
+          <a:xfrm>
+            <a:off x="4314825" y="5638800"/>
+            <a:ext cx="3419475" cy="323850"/>
+          </a:xfrm>
+          <a:prstGeom prst="rect">
+            <a:avLst/>
+          </a:prstGeom>
+          <a:noFill/>
+        </p:spPr>
+        <p:txBody>
+          <a:bodyPr wrap="square">
+            <a:spAutoFit/>
+          </a:bodyPr>
+          <a:lstStyle/>
+          <a:p>
+            <a:pPr algn="ctr"/>
+            <a:r>
+              <a:rPr sz="950" b="0">
+                <a:solidFill>
+                  <a:srgbClr val="222222"/>
+                </a:solidFill>
+                <a:latin typeface="Arial"/>
+                <a:ea typeface="AppleGothic"/>
+              </a:rPr>
+              <a:t>현재값 대신 causal</a:t>
+            </a:r>
+          </a:p>
+          <a:p>
+            <a:pPr algn="ctr"/>
+            <a:r>
+              <a:rPr sz="950" b="0">
+                <a:solidFill>
+                  <a:srgbClr val="222222"/>
+                </a:solidFill>
+                <a:latin typeface="Arial"/>
+                <a:ea typeface="AppleGothic"/>
+              </a:rPr>
+              <a:t>다중시간척도 입력</a:t>
+            </a:r>
+          </a:p>
+        </p:txBody>
+      </p:sp>
+      <p:sp>
+        <p:nvSpPr>
+          <p:cNvPr id="48" name="Rounded Rectangle 47"/>
+          <p:cNvSpPr/>
+          <p:nvPr/>
+        </p:nvSpPr>
+        <p:spPr>
+          <a:xfrm>
+            <a:off x="8020050" y="5391150"/>
+            <a:ext cx="3571875" cy="647700"/>
+          </a:xfrm>
+          <a:prstGeom prst="roundRect">
+            <a:avLst/>
+          </a:prstGeom>
+          <a:solidFill>
+            <a:srgbClr val="FDF4E3"/>
+          </a:solidFill>
+          <a:ln w="15875">
+            <a:solidFill>
+              <a:srgbClr val="E69F00"/>
+            </a:solidFill>
+          </a:ln>
+        </p:spPr>
+        <p:style>
+          <a:lnRef idx="1">
+            <a:schemeClr val="accent1"/>
+          </a:lnRef>
+          <a:fillRef idx="3">
+            <a:schemeClr val="accent1"/>
+          </a:fillRef>
+          <a:effectRef idx="2">
+            <a:schemeClr val="accent1"/>
+          </a:effectRef>
+          <a:fontRef idx="minor">
+            <a:schemeClr val="lt1"/>
+          </a:fontRef>
+        </p:style>
+        <p:txBody>
+          <a:bodyPr rtlCol="0" anchor="ctr"/>
+          <a:lstStyle/>
+          <a:p>
+            <a:pPr algn="ctr"/>
+          </a:p>
+        </p:txBody>
+      </p:sp>
+      <p:sp>
+        <p:nvSpPr>
+          <p:cNvPr id="49" name="TextBox 48"/>
+          <p:cNvSpPr txBox="1"/>
+          <p:nvPr/>
+        </p:nvSpPr>
+        <p:spPr>
+          <a:xfrm>
+            <a:off x="8096250" y="5448300"/>
+            <a:ext cx="3419475" cy="171450"/>
+          </a:xfrm>
+          <a:prstGeom prst="rect">
+            <a:avLst/>
+          </a:prstGeom>
+          <a:noFill/>
+        </p:spPr>
+        <p:txBody>
+          <a:bodyPr wrap="square">
+            <a:spAutoFit/>
+          </a:bodyPr>
+          <a:lstStyle/>
+          <a:p>
+            <a:pPr algn="ctr"/>
+            <a:r>
+              <a:rPr sz="1050" b="1">
+                <a:solidFill>
+                  <a:srgbClr val="E69F00"/>
+                </a:solidFill>
+                <a:latin typeface="Arial"/>
+                <a:ea typeface="AppleGothic"/>
+              </a:rPr>
+              <a:t>direct fallback</a:t>
+            </a:r>
+          </a:p>
+        </p:txBody>
+      </p:sp>
+      <p:sp>
+        <p:nvSpPr>
+          <p:cNvPr id="50" name="TextBox 49"/>
+          <p:cNvSpPr txBox="1"/>
+          <p:nvPr/>
+        </p:nvSpPr>
+        <p:spPr>
+          <a:xfrm>
+            <a:off x="8096250" y="5638800"/>
+            <a:ext cx="3419475" cy="323850"/>
+          </a:xfrm>
+          <a:prstGeom prst="rect">
+            <a:avLst/>
+          </a:prstGeom>
+          <a:noFill/>
+        </p:spPr>
+        <p:txBody>
+          <a:bodyPr wrap="square">
+            <a:spAutoFit/>
+          </a:bodyPr>
+          <a:lstStyle/>
+          <a:p>
+            <a:pPr algn="ctr"/>
+            <a:r>
+              <a:rPr sz="950" b="0">
+                <a:solidFill>
+                  <a:srgbClr val="222222"/>
+                </a:solidFill>
+                <a:latin typeface="Arial"/>
+                <a:ea typeface="AppleGothic"/>
+              </a:rPr>
+              <a:t>prior 없이 direct NN</a:t>
+            </a:r>
+          </a:p>
+          <a:p>
+            <a:pPr algn="ctr"/>
+            <a:r>
+              <a:rPr sz="950" b="0">
+                <a:solidFill>
+                  <a:srgbClr val="222222"/>
+                </a:solidFill>
+                <a:latin typeface="Arial"/>
+                <a:ea typeface="AppleGothic"/>
+              </a:rPr>
+              <a:t>Val FAIL 시 사용</a:t>
+            </a:r>
+          </a:p>
+        </p:txBody>
+      </p:sp>
     </p:spTree>
   </p:cSld>
   <p:clrMapOvr>

</xml_diff>